<commit_message>
szakdolgozat biralat es vedes
</commit_message>
<xml_diff>
--- a/szakdoga/szakdolgozat_vedes.pptx
+++ b/szakdoga/szakdolgozat_vedes.pptx
@@ -5,7 +5,7 @@
     <p:sldMasterId id="2147483648" r:id="rId1"/>
   </p:sldMasterIdLst>
   <p:notesMasterIdLst>
-    <p:notesMasterId r:id="rId33"/>
+    <p:notesMasterId r:id="rId35"/>
   </p:notesMasterIdLst>
   <p:sldIdLst>
     <p:sldId id="256" r:id="rId2"/>
@@ -32,13 +32,15 @@
     <p:sldId id="279" r:id="rId23"/>
     <p:sldId id="282" r:id="rId24"/>
     <p:sldId id="289" r:id="rId25"/>
-    <p:sldId id="283" r:id="rId26"/>
-    <p:sldId id="290" r:id="rId27"/>
-    <p:sldId id="284" r:id="rId28"/>
-    <p:sldId id="285" r:id="rId29"/>
-    <p:sldId id="286" r:id="rId30"/>
-    <p:sldId id="287" r:id="rId31"/>
-    <p:sldId id="260" r:id="rId32"/>
+    <p:sldId id="291" r:id="rId26"/>
+    <p:sldId id="260" r:id="rId27"/>
+    <p:sldId id="292" r:id="rId28"/>
+    <p:sldId id="283" r:id="rId29"/>
+    <p:sldId id="290" r:id="rId30"/>
+    <p:sldId id="284" r:id="rId31"/>
+    <p:sldId id="285" r:id="rId32"/>
+    <p:sldId id="286" r:id="rId33"/>
+    <p:sldId id="287" r:id="rId34"/>
   </p:sldIdLst>
   <p:sldSz cx="12192000" cy="6858000"/>
   <p:notesSz cx="6858000" cy="9144000"/>
@@ -227,7 +229,7 @@
           <a:p>
             <a:fld id="{0AB5BC8E-5813-4F4E-B35B-0E3B0D0BF7D5}" type="datetimeFigureOut">
               <a:rPr lang="hu-HU" smtClean="0"/>
-              <a:t>2025. 12. 28.</a:t>
+              <a:t>2026. 01. 05.</a:t>
             </a:fld>
             <a:endParaRPr lang="hu-HU"/>
           </a:p>
@@ -3486,101 +3488,7 @@
           <a:bodyPr/>
           <a:lstStyle/>
           <a:p>
-            <a:r>
-              <a:rPr lang="hu-HU" dirty="0" err="1"/>
-              <a:t>All-MiniLM</a:t>
-            </a:r>
-            <a:r>
-              <a:rPr lang="hu-HU" dirty="0"/>
-              <a:t> modell </a:t>
-            </a:r>
-            <a:r>
-              <a:rPr lang="hu-HU" b="0" dirty="0"/>
-              <a:t>páros mondat-reprezentációra lett </a:t>
-            </a:r>
-            <a:r>
-              <a:rPr lang="hu-HU" b="0" dirty="0" err="1"/>
-              <a:t>finomhangolva</a:t>
-            </a:r>
-            <a:r>
-              <a:rPr lang="hu-HU" b="0" dirty="0"/>
-              <a:t> (QA-pár adatokat)</a:t>
-            </a:r>
-          </a:p>
-          <a:p>
-            <a:r>
-              <a:rPr lang="hu-HU" b="0" dirty="0" err="1"/>
-              <a:t>Snowflake</a:t>
-            </a:r>
-            <a:r>
-              <a:rPr lang="hu-HU" b="0" dirty="0"/>
-              <a:t> </a:t>
-            </a:r>
-            <a:r>
-              <a:rPr lang="hu-HU" b="0" dirty="0" err="1"/>
-              <a:t>arctic</a:t>
-            </a:r>
-            <a:r>
-              <a:rPr lang="hu-HU" b="0" dirty="0"/>
-              <a:t> </a:t>
-            </a:r>
-            <a:r>
-              <a:rPr lang="hu-HU" b="0" dirty="0" err="1"/>
-              <a:t>embed</a:t>
-            </a:r>
-            <a:r>
-              <a:rPr lang="hu-HU" b="0" dirty="0"/>
-              <a:t>: univerzális, </a:t>
-            </a:r>
-            <a:r>
-              <a:rPr lang="hu-HU" b="0" dirty="0" err="1"/>
-              <a:t>general</a:t>
-            </a:r>
-            <a:r>
-              <a:rPr lang="hu-HU" b="0" dirty="0"/>
-              <a:t> </a:t>
-            </a:r>
-            <a:r>
-              <a:rPr lang="hu-HU" b="0" dirty="0" err="1"/>
-              <a:t>purpose</a:t>
-            </a:r>
-            <a:r>
-              <a:rPr lang="hu-HU" b="0" dirty="0"/>
-              <a:t> </a:t>
-            </a:r>
-            <a:r>
-              <a:rPr lang="hu-HU" b="0" dirty="0" err="1"/>
-              <a:t>embedder</a:t>
-            </a:r>
-            <a:endParaRPr lang="hu-HU" b="0" dirty="0"/>
-          </a:p>
-          <a:p>
-            <a:endParaRPr lang="hu-HU" dirty="0"/>
-          </a:p>
-          <a:p>
-            <a:r>
-              <a:rPr lang="hu-HU" dirty="0"/>
-              <a:t>Azon volt a lényeg a </a:t>
-            </a:r>
-            <a:r>
-              <a:rPr lang="hu-HU" dirty="0" err="1"/>
-              <a:t>szempontomből</a:t>
-            </a:r>
-            <a:r>
-              <a:rPr lang="hu-HU" dirty="0"/>
-              <a:t>, hogy a dimenziószám legyen más. Nem elsősorban a pontosság növelés volt a cél, a trendek megismerése. Konzisztensen ugyanazokat az </a:t>
-            </a:r>
-            <a:r>
-              <a:rPr lang="hu-HU" dirty="0" err="1"/>
-              <a:t>embeddingeket</a:t>
-            </a:r>
-            <a:r>
-              <a:rPr lang="hu-HU" dirty="0"/>
-              <a:t> használtam, így az eredmények is konzisztensek és általánosíthatóak.</a:t>
-            </a:r>
-          </a:p>
-          <a:p>
-            <a:endParaRPr lang="hu-HU" dirty="0"/>
+            <a:endParaRPr lang="hu-HU"/>
           </a:p>
         </p:txBody>
       </p:sp>
@@ -3601,7 +3509,7 @@
           <a:p>
             <a:fld id="{FEBF544B-8942-4253-A6F4-42DBF943B8C6}" type="slidenum">
               <a:rPr lang="hu-HU" smtClean="0"/>
-              <a:t>25</a:t>
+              <a:t>26</a:t>
             </a:fld>
             <a:endParaRPr lang="hu-HU"/>
           </a:p>
@@ -3610,7 +3518,7 @@
     </p:spTree>
     <p:extLst>
       <p:ext uri="{BB962C8B-B14F-4D97-AF65-F5344CB8AC3E}">
-        <p14:creationId xmlns:p14="http://schemas.microsoft.com/office/powerpoint/2010/main" val="2953331791"/>
+        <p14:creationId xmlns:p14="http://schemas.microsoft.com/office/powerpoint/2010/main" val="552155004"/>
       </p:ext>
     </p:extLst>
   </p:cSld>
@@ -3665,9 +3573,100 @@
           <a:lstStyle/>
           <a:p>
             <a:r>
-              <a:rPr lang="hu-HU" dirty="0"/>
-              <a:t>1024 dimenziós vektorokra a kiértékelés</a:t>
-            </a:r>
+              <a:rPr lang="hu-HU" dirty="0" err="1"/>
+              <a:t>All-MiniLM</a:t>
+            </a:r>
+            <a:r>
+              <a:rPr lang="hu-HU" dirty="0"/>
+              <a:t> modell </a:t>
+            </a:r>
+            <a:r>
+              <a:rPr lang="hu-HU" b="0" dirty="0"/>
+              <a:t>páros mondat-reprezentációra lett </a:t>
+            </a:r>
+            <a:r>
+              <a:rPr lang="hu-HU" b="0" dirty="0" err="1"/>
+              <a:t>finomhangolva</a:t>
+            </a:r>
+            <a:r>
+              <a:rPr lang="hu-HU" b="0" dirty="0"/>
+              <a:t> (QA-pár adatokat)</a:t>
+            </a:r>
+          </a:p>
+          <a:p>
+            <a:r>
+              <a:rPr lang="hu-HU" b="0" dirty="0" err="1"/>
+              <a:t>Snowflake</a:t>
+            </a:r>
+            <a:r>
+              <a:rPr lang="hu-HU" b="0" dirty="0"/>
+              <a:t> </a:t>
+            </a:r>
+            <a:r>
+              <a:rPr lang="hu-HU" b="0" dirty="0" err="1"/>
+              <a:t>arctic</a:t>
+            </a:r>
+            <a:r>
+              <a:rPr lang="hu-HU" b="0" dirty="0"/>
+              <a:t> </a:t>
+            </a:r>
+            <a:r>
+              <a:rPr lang="hu-HU" b="0" dirty="0" err="1"/>
+              <a:t>embed</a:t>
+            </a:r>
+            <a:r>
+              <a:rPr lang="hu-HU" b="0" dirty="0"/>
+              <a:t>: univerzális, </a:t>
+            </a:r>
+            <a:r>
+              <a:rPr lang="hu-HU" b="0" dirty="0" err="1"/>
+              <a:t>general</a:t>
+            </a:r>
+            <a:r>
+              <a:rPr lang="hu-HU" b="0" dirty="0"/>
+              <a:t> </a:t>
+            </a:r>
+            <a:r>
+              <a:rPr lang="hu-HU" b="0" dirty="0" err="1"/>
+              <a:t>purpose</a:t>
+            </a:r>
+            <a:r>
+              <a:rPr lang="hu-HU" b="0" dirty="0"/>
+              <a:t> </a:t>
+            </a:r>
+            <a:r>
+              <a:rPr lang="hu-HU" b="0" dirty="0" err="1"/>
+              <a:t>embedder</a:t>
+            </a:r>
+            <a:endParaRPr lang="hu-HU" b="0" dirty="0"/>
+          </a:p>
+          <a:p>
+            <a:endParaRPr lang="hu-HU" dirty="0"/>
+          </a:p>
+          <a:p>
+            <a:r>
+              <a:rPr lang="hu-HU" dirty="0"/>
+              <a:t>Azon volt a lényeg a </a:t>
+            </a:r>
+            <a:r>
+              <a:rPr lang="hu-HU" dirty="0" err="1"/>
+              <a:t>szempontomből</a:t>
+            </a:r>
+            <a:r>
+              <a:rPr lang="hu-HU" dirty="0"/>
+              <a:t>, hogy a dimenziószám legyen más. Nem elsősorban a pontosság növelés volt a cél, a trendek megismerése. Konzisztensen ugyanazokat az </a:t>
+            </a:r>
+            <a:r>
+              <a:rPr lang="hu-HU" dirty="0" err="1"/>
+              <a:t>embeddingeket</a:t>
+            </a:r>
+            <a:r>
+              <a:rPr lang="hu-HU" dirty="0"/>
+              <a:t> használtam, így az eredmények is konzisztensek és általánosíthatóak.</a:t>
+            </a:r>
+          </a:p>
+          <a:p>
+            <a:endParaRPr lang="hu-HU" dirty="0"/>
           </a:p>
         </p:txBody>
       </p:sp>
@@ -3688,7 +3687,7 @@
           <a:p>
             <a:fld id="{FEBF544B-8942-4253-A6F4-42DBF943B8C6}" type="slidenum">
               <a:rPr lang="hu-HU" smtClean="0"/>
-              <a:t>26</a:t>
+              <a:t>28</a:t>
             </a:fld>
             <a:endParaRPr lang="hu-HU"/>
           </a:p>
@@ -3697,7 +3696,7 @@
     </p:spTree>
     <p:extLst>
       <p:ext uri="{BB962C8B-B14F-4D97-AF65-F5344CB8AC3E}">
-        <p14:creationId xmlns:p14="http://schemas.microsoft.com/office/powerpoint/2010/main" val="2472096673"/>
+        <p14:creationId xmlns:p14="http://schemas.microsoft.com/office/powerpoint/2010/main" val="2953331791"/>
       </p:ext>
     </p:extLst>
   </p:cSld>
@@ -3753,133 +3752,8 @@
           <a:p>
             <a:r>
               <a:rPr lang="hu-HU" dirty="0"/>
-              <a:t>IVF: rögzített klaszterszám, nincsenek új klaszterek</a:t>
-            </a:r>
-          </a:p>
-          <a:p>
-            <a:endParaRPr lang="hu-HU" dirty="0"/>
-          </a:p>
-          <a:p>
-            <a:r>
-              <a:rPr lang="hu-HU" b="1" dirty="0"/>
-              <a:t>Kifejezett probléma lehet ha nincs tanító adat, teljes streaming környezet, adateltolódás</a:t>
-            </a:r>
-          </a:p>
-          <a:p>
-            <a:endParaRPr lang="hu-HU" dirty="0"/>
-          </a:p>
-          <a:p>
-            <a:r>
-              <a:rPr lang="hu-HU" dirty="0"/>
-              <a:t>Van egy </a:t>
-            </a:r>
-            <a:r>
-              <a:rPr lang="hu-HU" dirty="0" err="1"/>
-              <a:t>train</a:t>
-            </a:r>
-            <a:r>
-              <a:rPr lang="hu-HU" dirty="0"/>
-              <a:t> fázis ahol elkészülnek a klaszterek és utána az új vektor a legközelebbi klaszterekbe kerül. Nem frissül a </a:t>
-            </a:r>
-            <a:r>
-              <a:rPr lang="hu-HU" dirty="0" err="1"/>
-              <a:t>klaszterezés</a:t>
-            </a:r>
-            <a:r>
-              <a:rPr lang="hu-HU" dirty="0"/>
-              <a:t>.</a:t>
-            </a:r>
-          </a:p>
-          <a:p>
-            <a:r>
-              <a:rPr lang="hu-HU" dirty="0"/>
-              <a:t>Még ha a </a:t>
-            </a:r>
-            <a:r>
-              <a:rPr lang="hu-HU" dirty="0" err="1"/>
-              <a:t>klaszterezés</a:t>
-            </a:r>
-            <a:r>
-              <a:rPr lang="hu-HU" dirty="0"/>
-              <a:t> nagyon gyors is, nehéz ilyen gyorsan meghatározni, mi a helyes új klaszterszám.</a:t>
-            </a:r>
-          </a:p>
-          <a:p>
-            <a:endParaRPr lang="hu-HU" dirty="0"/>
-          </a:p>
-          <a:p>
-            <a:r>
-              <a:rPr lang="hu-HU" dirty="0"/>
-              <a:t>Ha változik az adatok eloszlása időben a </a:t>
-            </a:r>
-            <a:r>
-              <a:rPr lang="hu-HU" dirty="0" err="1"/>
-              <a:t>retrieval</a:t>
-            </a:r>
-            <a:r>
-              <a:rPr lang="hu-HU" dirty="0"/>
-              <a:t> minősége romolhat, ha csak nem lesz elkészítve a </a:t>
-            </a:r>
-            <a:r>
-              <a:rPr lang="hu-HU" dirty="0" err="1"/>
-              <a:t>klaszterezés</a:t>
-            </a:r>
-            <a:r>
-              <a:rPr lang="hu-HU" dirty="0"/>
-              <a:t> újra, új klaszterszámmal.</a:t>
-            </a:r>
-          </a:p>
-          <a:p>
-            <a:r>
-              <a:rPr lang="hu-HU" b="1" dirty="0"/>
-              <a:t>HNSW </a:t>
-            </a:r>
-            <a:r>
-              <a:rPr lang="hu-HU" b="1" dirty="0" err="1"/>
-              <a:t>can</a:t>
-            </a:r>
-            <a:r>
-              <a:rPr lang="hu-HU" b="1" dirty="0"/>
-              <a:t> </a:t>
-            </a:r>
-            <a:r>
-              <a:rPr lang="hu-HU" b="1" dirty="0" err="1"/>
-              <a:t>reorganize</a:t>
-            </a:r>
-            <a:r>
-              <a:rPr lang="hu-HU" b="1" dirty="0"/>
-              <a:t> </a:t>
-            </a:r>
-            <a:r>
-              <a:rPr lang="hu-HU" b="1" dirty="0" err="1"/>
-              <a:t>itself</a:t>
-            </a:r>
-            <a:r>
-              <a:rPr lang="hu-HU" b="1" dirty="0"/>
-              <a:t>, </a:t>
-            </a:r>
-            <a:r>
-              <a:rPr lang="hu-HU" b="0" dirty="0"/>
-              <a:t>ez volt a releváns módszer a szempontomból, amihez hasonlítani kellett.</a:t>
-            </a:r>
-          </a:p>
-          <a:p>
-            <a:endParaRPr lang="hu-HU" b="0" dirty="0"/>
-          </a:p>
-          <a:p>
-            <a:r>
-              <a:rPr lang="hu-HU" b="0" dirty="0"/>
-              <a:t>Jövőben </a:t>
-            </a:r>
-            <a:r>
-              <a:rPr lang="hu-HU" b="0" dirty="0" err="1"/>
-              <a:t>OnlineKMeans</a:t>
-            </a:r>
-            <a:r>
-              <a:rPr lang="hu-HU" b="0" dirty="0"/>
-              <a:t> + FAISS összevonása</a:t>
-            </a:r>
-            <a:endParaRPr lang="hu-HU" b="1" dirty="0"/>
+              <a:t>1024 dimenziós vektorokra a kiértékelés</a:t>
+            </a:r>
           </a:p>
         </p:txBody>
       </p:sp>
@@ -3900,7 +3774,7 @@
           <a:p>
             <a:fld id="{FEBF544B-8942-4253-A6F4-42DBF943B8C6}" type="slidenum">
               <a:rPr lang="hu-HU" smtClean="0"/>
-              <a:t>28</a:t>
+              <a:t>29</a:t>
             </a:fld>
             <a:endParaRPr lang="hu-HU"/>
           </a:p>
@@ -3909,7 +3783,7 @@
     </p:spTree>
     <p:extLst>
       <p:ext uri="{BB962C8B-B14F-4D97-AF65-F5344CB8AC3E}">
-        <p14:creationId xmlns:p14="http://schemas.microsoft.com/office/powerpoint/2010/main" val="3312740467"/>
+        <p14:creationId xmlns:p14="http://schemas.microsoft.com/office/powerpoint/2010/main" val="2472096673"/>
       </p:ext>
     </p:extLst>
   </p:cSld>
@@ -3965,7 +3839,33 @@
           <a:p>
             <a:r>
               <a:rPr lang="hu-HU" dirty="0"/>
-              <a:t>Ezeknek az értékeknek a megválasztása a </a:t>
+              <a:t>IVF: rögzített klaszterszám, nincsenek új klaszterek</a:t>
+            </a:r>
+          </a:p>
+          <a:p>
+            <a:endParaRPr lang="hu-HU" dirty="0"/>
+          </a:p>
+          <a:p>
+            <a:r>
+              <a:rPr lang="hu-HU" b="1" dirty="0"/>
+              <a:t>Kifejezett probléma lehet ha nincs tanító adat, teljes streaming környezet, adateltolódás</a:t>
+            </a:r>
+          </a:p>
+          <a:p>
+            <a:endParaRPr lang="hu-HU" dirty="0"/>
+          </a:p>
+          <a:p>
+            <a:r>
+              <a:rPr lang="hu-HU" dirty="0"/>
+              <a:t>Van egy </a:t>
+            </a:r>
+            <a:r>
+              <a:rPr lang="hu-HU" dirty="0" err="1"/>
+              <a:t>train</a:t>
+            </a:r>
+            <a:r>
+              <a:rPr lang="hu-HU" dirty="0"/>
+              <a:t> fázis ahol elkészülnek a klaszterek és utána az új vektor a legközelebbi klaszterekbe kerül. Nem frissül a </a:t>
             </a:r>
             <a:r>
               <a:rPr lang="hu-HU" dirty="0" err="1"/>
@@ -3973,16 +3873,99 @@
             </a:r>
             <a:r>
               <a:rPr lang="hu-HU" dirty="0"/>
-              <a:t> eredményeinek szempontjából kritikus, mint </a:t>
+              <a:t>.</a:t>
+            </a:r>
+          </a:p>
+          <a:p>
+            <a:r>
+              <a:rPr lang="hu-HU" dirty="0"/>
+              <a:t>Még ha a </a:t>
             </a:r>
             <a:r>
               <a:rPr lang="hu-HU" dirty="0" err="1"/>
-              <a:t>pl</a:t>
-            </a:r>
-            <a:r>
-              <a:rPr lang="hu-HU" dirty="0"/>
-              <a:t> DBSCAN esetén epszilon.</a:t>
-            </a:r>
+              <a:t>klaszterezés</a:t>
+            </a:r>
+            <a:r>
+              <a:rPr lang="hu-HU" dirty="0"/>
+              <a:t> nagyon gyors is, nehéz ilyen gyorsan meghatározni, mi a helyes új klaszterszám.</a:t>
+            </a:r>
+          </a:p>
+          <a:p>
+            <a:endParaRPr lang="hu-HU" dirty="0"/>
+          </a:p>
+          <a:p>
+            <a:r>
+              <a:rPr lang="hu-HU" dirty="0"/>
+              <a:t>Ha változik az adatok eloszlása időben a </a:t>
+            </a:r>
+            <a:r>
+              <a:rPr lang="hu-HU" dirty="0" err="1"/>
+              <a:t>retrieval</a:t>
+            </a:r>
+            <a:r>
+              <a:rPr lang="hu-HU" dirty="0"/>
+              <a:t> minősége romolhat, ha csak nem lesz elkészítve a </a:t>
+            </a:r>
+            <a:r>
+              <a:rPr lang="hu-HU" dirty="0" err="1"/>
+              <a:t>klaszterezés</a:t>
+            </a:r>
+            <a:r>
+              <a:rPr lang="hu-HU" dirty="0"/>
+              <a:t> újra, új klaszterszámmal.</a:t>
+            </a:r>
+          </a:p>
+          <a:p>
+            <a:r>
+              <a:rPr lang="hu-HU" b="1" dirty="0"/>
+              <a:t>HNSW </a:t>
+            </a:r>
+            <a:r>
+              <a:rPr lang="hu-HU" b="1" dirty="0" err="1"/>
+              <a:t>can</a:t>
+            </a:r>
+            <a:r>
+              <a:rPr lang="hu-HU" b="1" dirty="0"/>
+              <a:t> </a:t>
+            </a:r>
+            <a:r>
+              <a:rPr lang="hu-HU" b="1" dirty="0" err="1"/>
+              <a:t>reorganize</a:t>
+            </a:r>
+            <a:r>
+              <a:rPr lang="hu-HU" b="1" dirty="0"/>
+              <a:t> </a:t>
+            </a:r>
+            <a:r>
+              <a:rPr lang="hu-HU" b="1" dirty="0" err="1"/>
+              <a:t>itself</a:t>
+            </a:r>
+            <a:r>
+              <a:rPr lang="hu-HU" b="1" dirty="0"/>
+              <a:t>, </a:t>
+            </a:r>
+            <a:r>
+              <a:rPr lang="hu-HU" b="0" dirty="0"/>
+              <a:t>ez volt a releváns módszer a szempontomból, amihez hasonlítani kellett.</a:t>
+            </a:r>
+          </a:p>
+          <a:p>
+            <a:endParaRPr lang="hu-HU" b="0" dirty="0"/>
+          </a:p>
+          <a:p>
+            <a:r>
+              <a:rPr lang="hu-HU" b="0" dirty="0"/>
+              <a:t>Jövőben </a:t>
+            </a:r>
+            <a:r>
+              <a:rPr lang="hu-HU" b="0" dirty="0" err="1"/>
+              <a:t>OnlineKMeans</a:t>
+            </a:r>
+            <a:r>
+              <a:rPr lang="hu-HU" b="0" dirty="0"/>
+              <a:t> + FAISS összevonása</a:t>
+            </a:r>
+            <a:endParaRPr lang="hu-HU" b="1" dirty="0"/>
           </a:p>
         </p:txBody>
       </p:sp>
@@ -4003,7 +3986,7 @@
           <a:p>
             <a:fld id="{FEBF544B-8942-4253-A6F4-42DBF943B8C6}" type="slidenum">
               <a:rPr lang="hu-HU" smtClean="0"/>
-              <a:t>29</a:t>
+              <a:t>31</a:t>
             </a:fld>
             <a:endParaRPr lang="hu-HU"/>
           </a:p>
@@ -4012,7 +3995,7 @@
     </p:spTree>
     <p:extLst>
       <p:ext uri="{BB962C8B-B14F-4D97-AF65-F5344CB8AC3E}">
-        <p14:creationId xmlns:p14="http://schemas.microsoft.com/office/powerpoint/2010/main" val="3128718055"/>
+        <p14:creationId xmlns:p14="http://schemas.microsoft.com/office/powerpoint/2010/main" val="3312740467"/>
       </p:ext>
     </p:extLst>
   </p:cSld>
@@ -4066,76 +4049,25 @@
           <a:bodyPr/>
           <a:lstStyle/>
           <a:p>
-            <a:pPr marL="228600" indent="-228600">
-              <a:buAutoNum type="arabicPeriod"/>
-            </a:pPr>
-            <a:r>
-              <a:rPr lang="hu-HU" dirty="0"/>
-              <a:t>normalizálás, mátrixszorzás</a:t>
-            </a:r>
-          </a:p>
-          <a:p>
-            <a:pPr marL="228600" indent="-228600">
-              <a:buAutoNum type="arabicPeriod"/>
-            </a:pPr>
-            <a:r>
-              <a:rPr lang="hu-HU" dirty="0"/>
-              <a:t>Min távolság kiválasztása</a:t>
-            </a:r>
-          </a:p>
-          <a:p>
-            <a:pPr marL="228600" indent="-228600">
-              <a:buAutoNum type="arabicPeriod"/>
-            </a:pPr>
-            <a:r>
-              <a:rPr lang="hu-HU" dirty="0"/>
-              <a:t>Maximum (</a:t>
+            <a:r>
+              <a:rPr lang="hu-HU" dirty="0"/>
+              <a:t>Ezeknek az értékeknek a megválasztása a </a:t>
             </a:r>
             <a:r>
               <a:rPr lang="hu-HU" dirty="0" err="1"/>
-              <a:t>max_clusters</a:t>
-            </a:r>
-            <a:r>
-              <a:rPr lang="hu-HU" dirty="0"/>
-              <a:t> - </a:t>
+              <a:t>klaszterezés</a:t>
+            </a:r>
+            <a:r>
+              <a:rPr lang="hu-HU" dirty="0"/>
+              <a:t> eredményeinek szempontjából kritikus, mint </a:t>
             </a:r>
             <a:r>
               <a:rPr lang="hu-HU" dirty="0" err="1"/>
-              <a:t>k</a:t>
-            </a:r>
-            <a:r>
-              <a:rPr lang="hu-HU" dirty="0"/>
-              <a:t>) új jöhet létre</a:t>
-            </a:r>
-          </a:p>
-          <a:p>
-            <a:pPr marL="228600" indent="-228600">
-              <a:buAutoNum type="arabicPeriod"/>
-            </a:pPr>
-            <a:r>
-              <a:rPr lang="hu-HU" dirty="0" err="1"/>
-              <a:t>Centroid</a:t>
-            </a:r>
-            <a:r>
-              <a:rPr lang="hu-HU" dirty="0"/>
-              <a:t> frissítés: minden pontot egyszer összeadunk</a:t>
-            </a:r>
-          </a:p>
-          <a:p>
-            <a:pPr marL="228600" indent="-228600">
-              <a:buAutoNum type="arabicPeriod"/>
-            </a:pPr>
-            <a:r>
-              <a:rPr lang="hu-HU" dirty="0"/>
-              <a:t>Klaszterek közötti </a:t>
-            </a:r>
-            <a:r>
-              <a:rPr lang="hu-HU" dirty="0" err="1"/>
-              <a:t>páronkénti</a:t>
-            </a:r>
-            <a:r>
-              <a:rPr lang="hu-HU" dirty="0"/>
-              <a:t> távolság számítása</a:t>
+              <a:t>pl</a:t>
+            </a:r>
+            <a:r>
+              <a:rPr lang="hu-HU" dirty="0"/>
+              <a:t> DBSCAN esetén epszilon.</a:t>
             </a:r>
           </a:p>
         </p:txBody>
@@ -4157,7 +4089,7 @@
           <a:p>
             <a:fld id="{FEBF544B-8942-4253-A6F4-42DBF943B8C6}" type="slidenum">
               <a:rPr lang="hu-HU" smtClean="0"/>
-              <a:t>30</a:t>
+              <a:t>32</a:t>
             </a:fld>
             <a:endParaRPr lang="hu-HU"/>
           </a:p>
@@ -4166,7 +4098,7 @@
     </p:spTree>
     <p:extLst>
       <p:ext uri="{BB962C8B-B14F-4D97-AF65-F5344CB8AC3E}">
-        <p14:creationId xmlns:p14="http://schemas.microsoft.com/office/powerpoint/2010/main" val="1399101224"/>
+        <p14:creationId xmlns:p14="http://schemas.microsoft.com/office/powerpoint/2010/main" val="3128718055"/>
       </p:ext>
     </p:extLst>
   </p:cSld>
@@ -4326,7 +4258,77 @@
           <a:bodyPr/>
           <a:lstStyle/>
           <a:p>
-            <a:endParaRPr lang="hu-HU"/>
+            <a:pPr marL="228600" indent="-228600">
+              <a:buAutoNum type="arabicPeriod"/>
+            </a:pPr>
+            <a:r>
+              <a:rPr lang="hu-HU" dirty="0"/>
+              <a:t>normalizálás, mátrixszorzás</a:t>
+            </a:r>
+          </a:p>
+          <a:p>
+            <a:pPr marL="228600" indent="-228600">
+              <a:buAutoNum type="arabicPeriod"/>
+            </a:pPr>
+            <a:r>
+              <a:rPr lang="hu-HU" dirty="0"/>
+              <a:t>Min távolság kiválasztása</a:t>
+            </a:r>
+          </a:p>
+          <a:p>
+            <a:pPr marL="228600" indent="-228600">
+              <a:buAutoNum type="arabicPeriod"/>
+            </a:pPr>
+            <a:r>
+              <a:rPr lang="hu-HU" dirty="0"/>
+              <a:t>Maximum (</a:t>
+            </a:r>
+            <a:r>
+              <a:rPr lang="hu-HU" dirty="0" err="1"/>
+              <a:t>max_clusters</a:t>
+            </a:r>
+            <a:r>
+              <a:rPr lang="hu-HU" dirty="0"/>
+              <a:t> - </a:t>
+            </a:r>
+            <a:r>
+              <a:rPr lang="hu-HU" dirty="0" err="1"/>
+              <a:t>k</a:t>
+            </a:r>
+            <a:r>
+              <a:rPr lang="hu-HU" dirty="0"/>
+              <a:t>) új jöhet létre</a:t>
+            </a:r>
+          </a:p>
+          <a:p>
+            <a:pPr marL="228600" indent="-228600">
+              <a:buAutoNum type="arabicPeriod"/>
+            </a:pPr>
+            <a:r>
+              <a:rPr lang="hu-HU" dirty="0" err="1"/>
+              <a:t>Centroid</a:t>
+            </a:r>
+            <a:r>
+              <a:rPr lang="hu-HU" dirty="0"/>
+              <a:t> frissítés: minden pontot egyszer összeadunk</a:t>
+            </a:r>
+          </a:p>
+          <a:p>
+            <a:pPr marL="228600" indent="-228600">
+              <a:buAutoNum type="arabicPeriod"/>
+            </a:pPr>
+            <a:r>
+              <a:rPr lang="hu-HU" dirty="0"/>
+              <a:t>Klaszterek közötti </a:t>
+            </a:r>
+            <a:r>
+              <a:rPr lang="hu-HU" dirty="0" err="1"/>
+              <a:t>páronkénti</a:t>
+            </a:r>
+            <a:r>
+              <a:rPr lang="hu-HU" dirty="0"/>
+              <a:t> távolság számítása</a:t>
+            </a:r>
           </a:p>
         </p:txBody>
       </p:sp>
@@ -4347,7 +4349,7 @@
           <a:p>
             <a:fld id="{FEBF544B-8942-4253-A6F4-42DBF943B8C6}" type="slidenum">
               <a:rPr lang="hu-HU" smtClean="0"/>
-              <a:t>31</a:t>
+              <a:t>33</a:t>
             </a:fld>
             <a:endParaRPr lang="hu-HU"/>
           </a:p>
@@ -4356,7 +4358,7 @@
     </p:spTree>
     <p:extLst>
       <p:ext uri="{BB962C8B-B14F-4D97-AF65-F5344CB8AC3E}">
-        <p14:creationId xmlns:p14="http://schemas.microsoft.com/office/powerpoint/2010/main" val="552155004"/>
+        <p14:creationId xmlns:p14="http://schemas.microsoft.com/office/powerpoint/2010/main" val="1399101224"/>
       </p:ext>
     </p:extLst>
   </p:cSld>
@@ -5537,7 +5539,7 @@
           <a:p>
             <a:fld id="{D45F21B2-F76C-DA4E-93C7-1ED776993694}" type="datetime1">
               <a:rPr lang="hu-HU" smtClean="0"/>
-              <a:t>2025. 12. 28.</a:t>
+              <a:t>2026. 01. 05.</a:t>
             </a:fld>
             <a:endParaRPr lang="hu-HU"/>
           </a:p>
@@ -5738,7 +5740,7 @@
           <a:p>
             <a:fld id="{639F617D-633B-144B-B338-1A3186D94DEC}" type="datetime1">
               <a:rPr lang="hu-HU" smtClean="0"/>
-              <a:t>2025. 12. 28.</a:t>
+              <a:t>2026. 01. 05.</a:t>
             </a:fld>
             <a:endParaRPr lang="hu-HU"/>
           </a:p>
@@ -5946,7 +5948,7 @@
           <a:p>
             <a:fld id="{EB40C74A-E794-5D4C-99F0-E0908F250C85}" type="datetime1">
               <a:rPr lang="hu-HU" smtClean="0"/>
-              <a:t>2025. 12. 28.</a:t>
+              <a:t>2026. 01. 05.</a:t>
             </a:fld>
             <a:endParaRPr lang="hu-HU"/>
           </a:p>
@@ -6144,7 +6146,7 @@
           <a:p>
             <a:fld id="{FB2979DB-241A-8544-95D6-5A5515E861C2}" type="datetime1">
               <a:rPr lang="hu-HU" smtClean="0"/>
-              <a:t>2025. 12. 28.</a:t>
+              <a:t>2026. 01. 05.</a:t>
             </a:fld>
             <a:endParaRPr lang="hu-HU"/>
           </a:p>
@@ -6419,7 +6421,7 @@
           <a:p>
             <a:fld id="{E1238A03-143C-DC48-B6FB-03520BF3D264}" type="datetime1">
               <a:rPr lang="hu-HU" smtClean="0"/>
-              <a:t>2025. 12. 28.</a:t>
+              <a:t>2026. 01. 05.</a:t>
             </a:fld>
             <a:endParaRPr lang="hu-HU"/>
           </a:p>
@@ -6684,7 +6686,7 @@
           <a:p>
             <a:fld id="{32D5DABD-02F3-C24D-B459-BA5A52C7C0D3}" type="datetime1">
               <a:rPr lang="hu-HU" smtClean="0"/>
-              <a:t>2025. 12. 28.</a:t>
+              <a:t>2026. 01. 05.</a:t>
             </a:fld>
             <a:endParaRPr lang="hu-HU"/>
           </a:p>
@@ -7096,7 +7098,7 @@
           <a:p>
             <a:fld id="{B8F665F1-11A6-C146-8C9C-4EAD2B21F502}" type="datetime1">
               <a:rPr lang="hu-HU" smtClean="0"/>
-              <a:t>2025. 12. 28.</a:t>
+              <a:t>2026. 01. 05.</a:t>
             </a:fld>
             <a:endParaRPr lang="hu-HU"/>
           </a:p>
@@ -7237,7 +7239,7 @@
           <a:p>
             <a:fld id="{0505F671-323E-D34A-8D4F-5155E3541BC7}" type="datetime1">
               <a:rPr lang="hu-HU" smtClean="0"/>
-              <a:t>2025. 12. 28.</a:t>
+              <a:t>2026. 01. 05.</a:t>
             </a:fld>
             <a:endParaRPr lang="hu-HU"/>
           </a:p>
@@ -7350,7 +7352,7 @@
           <a:p>
             <a:fld id="{B3CDB417-D9D9-C740-B221-44D378005732}" type="datetime1">
               <a:rPr lang="hu-HU" smtClean="0"/>
-              <a:t>2025. 12. 28.</a:t>
+              <a:t>2026. 01. 05.</a:t>
             </a:fld>
             <a:endParaRPr lang="hu-HU"/>
           </a:p>
@@ -7661,7 +7663,7 @@
           <a:p>
             <a:fld id="{3980F3EA-3925-E241-9F9A-1E3EF43D2F81}" type="datetime1">
               <a:rPr lang="hu-HU" smtClean="0"/>
-              <a:t>2025. 12. 28.</a:t>
+              <a:t>2026. 01. 05.</a:t>
             </a:fld>
             <a:endParaRPr lang="hu-HU"/>
           </a:p>
@@ -7949,7 +7951,7 @@
           <a:p>
             <a:fld id="{662B74F7-95E0-1C4A-BBFA-D3DEF04605D4}" type="datetime1">
               <a:rPr lang="hu-HU" smtClean="0"/>
-              <a:t>2025. 12. 28.</a:t>
+              <a:t>2026. 01. 05.</a:t>
             </a:fld>
             <a:endParaRPr lang="hu-HU"/>
           </a:p>
@@ -8190,7 +8192,7 @@
           <a:p>
             <a:fld id="{E04DB062-3C69-2A49-980E-3FE962CDF110}" type="datetime1">
               <a:rPr lang="hu-HU" smtClean="0"/>
-              <a:t>2025. 12. 28.</a:t>
+              <a:t>2026. 01. 05.</a:t>
             </a:fld>
             <a:endParaRPr lang="hu-HU" dirty="0"/>
           </a:p>
@@ -9130,7 +9132,7 @@
           <a:p>
             <a:fld id="{78DF9215-F87C-794D-9DB3-DA814D7D6B51}" type="datetime1">
               <a:rPr lang="hu-HU" smtClean="0"/>
-              <a:t>2025. 12. 28.</a:t>
+              <a:t>2026. 01. 05.</a:t>
             </a:fld>
             <a:endParaRPr lang="hu-HU"/>
           </a:p>
@@ -9410,7 +9412,7 @@
           <a:p>
             <a:fld id="{16CFAA20-991C-5440-821D-EF7936105166}" type="datetime1">
               <a:rPr lang="hu-HU" smtClean="0"/>
-              <a:t>2025. 12. 28.</a:t>
+              <a:t>2026. 01. 05.</a:t>
             </a:fld>
             <a:endParaRPr lang="hu-HU"/>
           </a:p>
@@ -9572,7 +9574,7 @@
           <a:p>
             <a:fld id="{031D0D19-1B35-7A4F-93B5-1EDA6F972E33}" type="datetime1">
               <a:rPr lang="hu-HU" smtClean="0"/>
-              <a:t>2025. 12. 28.</a:t>
+              <a:t>2026. 01. 05.</a:t>
             </a:fld>
             <a:endParaRPr lang="hu-HU"/>
           </a:p>
@@ -9947,7 +9949,7 @@
           <a:p>
             <a:fld id="{F5CF19C3-C554-0D49-858F-BC5A4F8BAF23}" type="datetime1">
               <a:rPr lang="hu-HU" smtClean="0"/>
-              <a:t>2025. 12. 28.</a:t>
+              <a:t>2026. 01. 05.</a:t>
             </a:fld>
             <a:endParaRPr lang="hu-HU"/>
           </a:p>
@@ -10103,7 +10105,7 @@
           <a:p>
             <a:fld id="{86D7C4ED-070D-D147-BEC5-7EAE588D72B2}" type="datetime1">
               <a:rPr lang="hu-HU" smtClean="0"/>
-              <a:t>2025. 12. 28.</a:t>
+              <a:t>2026. 01. 05.</a:t>
             </a:fld>
             <a:endParaRPr lang="hu-HU"/>
           </a:p>
@@ -10345,7 +10347,7 @@
           <a:p>
             <a:fld id="{DB103250-059E-6C49-9AEC-D7E11F74EA17}" type="datetime1">
               <a:rPr lang="hu-HU" smtClean="0"/>
-              <a:t>2025. 12. 28.</a:t>
+              <a:t>2026. 01. 05.</a:t>
             </a:fld>
             <a:endParaRPr lang="hu-HU"/>
           </a:p>
@@ -10554,7 +10556,7 @@
           <a:p>
             <a:fld id="{CA3B4C4B-4FCE-684E-BDCF-894303FF802E}" type="datetime1">
               <a:rPr lang="hu-HU" smtClean="0"/>
-              <a:t>2025. 12. 28.</a:t>
+              <a:t>2026. 01. 05.</a:t>
             </a:fld>
             <a:endParaRPr lang="hu-HU"/>
           </a:p>
@@ -10875,7 +10877,7 @@
           <a:p>
             <a:fld id="{A1F67968-9289-324A-8185-9F1024D0E0BB}" type="datetime1">
               <a:rPr lang="hu-HU" smtClean="0"/>
-              <a:t>2025. 12. 28.</a:t>
+              <a:t>2026. 01. 05.</a:t>
             </a:fld>
             <a:endParaRPr lang="hu-HU"/>
           </a:p>
@@ -10996,7 +10998,7 @@
           <a:p>
             <a:fld id="{C19EC71B-C64D-AC47-B57B-94F3463CBF7C}" type="datetime1">
               <a:rPr lang="hu-HU" smtClean="0"/>
-              <a:t>2025. 12. 28.</a:t>
+              <a:t>2026. 01. 05.</a:t>
             </a:fld>
             <a:endParaRPr lang="hu-HU"/>
           </a:p>
@@ -11326,7 +11328,7 @@
           <a:p>
             <a:fld id="{9B9C5130-88B4-B04A-A570-CDDCA513217F}" type="datetime1">
               <a:rPr lang="hu-HU" smtClean="0"/>
-              <a:t>2025. 12. 28.</a:t>
+              <a:t>2026. 01. 05.</a:t>
             </a:fld>
             <a:endParaRPr lang="hu-HU"/>
           </a:p>
@@ -11982,7 +11984,7 @@
           <a:p>
             <a:fld id="{D3B9E4F3-2471-F946-A10E-F965F7F15FF3}" type="datetime1">
               <a:rPr lang="hu-HU" smtClean="0"/>
-              <a:t>2025. 12. 28.</a:t>
+              <a:t>2026. 01. 05.</a:t>
             </a:fld>
             <a:endParaRPr lang="hu-HU"/>
           </a:p>
@@ -12173,7 +12175,7 @@
           <a:p>
             <a:fld id="{C6ADFBD6-396A-C74B-847F-F81995866E7F}" type="datetime1">
               <a:rPr lang="hu-HU" smtClean="0"/>
-              <a:t>2025. 12. 28.</a:t>
+              <a:t>2026. 01. 05.</a:t>
             </a:fld>
             <a:endParaRPr lang="hu-HU"/>
           </a:p>
@@ -13231,7 +13233,7 @@
             </a:pPr>
             <a:fld id="{29D8A9DB-A63D-1E43-964A-FEA6F241DBC6}" type="datetime1">
               <a:rPr lang="hu-HU" smtClean="0"/>
-              <a:t>2025. 12. 28.</a:t>
+              <a:t>2026. 01. 05.</a:t>
             </a:fld>
             <a:endParaRPr lang="hu-HU"/>
           </a:p>
@@ -13944,7 +13946,7 @@
           <a:p>
             <a:r>
               <a:rPr lang="hu-HU" dirty="0"/>
-              <a:t>1. Bíráló – 1/3 kérdés</a:t>
+              <a:t>1. Kérdés</a:t>
             </a:r>
           </a:p>
         </p:txBody>
@@ -13967,34 +13969,73 @@
         </p:nvSpPr>
         <p:spPr/>
         <p:txBody>
-          <a:bodyPr/>
-          <a:lstStyle/>
-          <a:p>
-            <a:r>
-              <a:rPr lang="hu-HU" dirty="0"/>
-              <a:t>Az 5.2 fejezetben azt írja, hogy a dokumentumok 15%-át távolította el és 0.6-os hasonlósági küszöbértéket választott. Vizsgálta-e esetleg a teljesítményt más paraméter választás mellett? Mennyire érzékenyek az eredmények ezen paraméterekre?</a:t>
-            </a:r>
-          </a:p>
-          <a:p>
-            <a:endParaRPr lang="hu-HU" dirty="0"/>
-          </a:p>
+          <a:bodyPr>
+            <a:normAutofit/>
+          </a:bodyPr>
+          <a:lstStyle/>
           <a:p>
             <a:pPr marL="0" indent="0">
               <a:buNone/>
             </a:pPr>
             <a:r>
               <a:rPr lang="hu-HU" dirty="0"/>
-              <a:t>Válasz:</a:t>
+              <a:t>„A dolgozatban a </a:t>
+            </a:r>
+            <a:r>
+              <a:rPr lang="hu-HU" dirty="0" err="1"/>
+              <a:t>retrieval</a:t>
+            </a:r>
+            <a:r>
+              <a:rPr lang="hu-HU" dirty="0"/>
+              <a:t> során alkalmazott 0,6-os hasonlósági küszöbérték a </a:t>
+            </a:r>
+            <a:r>
+              <a:rPr lang="hu-HU" dirty="0" err="1"/>
+              <a:t>chunkolási</a:t>
+            </a:r>
+            <a:r>
+              <a:rPr lang="hu-HU" dirty="0"/>
+              <a:t> eljárásból származik. Milyen hatással lenne a rendszer teljesítményére ennek a paraméternek a változtatása?”</a:t>
             </a:r>
           </a:p>
           <a:p>
             <a:pPr marL="0" indent="0">
               <a:buNone/>
             </a:pPr>
-            <a:r>
-              <a:rPr lang="hu-HU" dirty="0"/>
-              <a:t>Főleg a hasonlósági küszöbérték megválasztásától függ a pontossági eredmény. A hiányzó dokumentumok aránya nem befolyásoló tényező.</a:t>
-            </a:r>
+            <a:endParaRPr lang="hu-HU" dirty="0"/>
+          </a:p>
+          <a:p>
+            <a:pPr marL="0" indent="0">
+              <a:buNone/>
+            </a:pPr>
+            <a:endParaRPr lang="hu-HU" dirty="0"/>
+          </a:p>
+          <a:p>
+            <a:pPr marL="0" indent="0">
+              <a:buNone/>
+            </a:pPr>
+            <a:r>
+              <a:rPr lang="hu-HU" dirty="0"/>
+              <a:t>A rendszer pontossága függ a paraméter megválasztásától.</a:t>
+            </a:r>
+          </a:p>
+          <a:p>
+            <a:r>
+              <a:rPr lang="hu-HU" dirty="0"/>
+              <a:t>Paraméter növelése: Növekvő hamis negatív arány</a:t>
+            </a:r>
+          </a:p>
+          <a:p>
+            <a:r>
+              <a:rPr lang="hu-HU" dirty="0"/>
+              <a:t>Paraméter csökkentése: Több zaj és hamis pozitív</a:t>
+            </a:r>
+          </a:p>
+          <a:p>
+            <a:pPr marL="0" indent="0">
+              <a:buNone/>
+            </a:pPr>
+            <a:endParaRPr lang="hu-HU" dirty="0"/>
           </a:p>
         </p:txBody>
       </p:sp>
@@ -14101,7 +14142,7 @@
           <a:p>
             <a:r>
               <a:rPr lang="hu-HU" dirty="0"/>
-              <a:t>1. Bíráló – 1/3 kérdés</a:t>
+              <a:t>1. Kérdés</a:t>
             </a:r>
           </a:p>
         </p:txBody>
@@ -14159,19 +14200,17 @@
       </p:sp>
       <p:pic>
         <p:nvPicPr>
-          <p:cNvPr id="25" name="Tartalom helye 24" descr="A képen szöveg, sor, Diagram, diagram látható&#10;&#10;Automatikusan generált leírás">
-            <a:extLst>
-              <a:ext uri="{FF2B5EF4-FFF2-40B4-BE49-F238E27FC236}">
-                <a16:creationId xmlns:a16="http://schemas.microsoft.com/office/drawing/2014/main" id="{CE0527A9-DCDC-7142-71A0-C91818F69241}"/>
+          <p:cNvPr id="27" name="Kép 26" descr="A képen szöveg, sor, Diagram, Betűtípus látható&#10;&#10;Automatikusan generált leírás">
+            <a:extLst>
+              <a:ext uri="{FF2B5EF4-FFF2-40B4-BE49-F238E27FC236}">
+                <a16:creationId xmlns:a16="http://schemas.microsoft.com/office/drawing/2014/main" id="{EFF63355-4441-C47C-C10A-AE24B3BE7656}"/>
               </a:ext>
             </a:extLst>
           </p:cNvPr>
           <p:cNvPicPr>
-            <a:picLocks noGrp="1" noChangeAspect="1"/>
+            <a:picLocks noChangeAspect="1"/>
           </p:cNvPicPr>
-          <p:nvPr>
-            <p:ph idx="1"/>
-          </p:nvPr>
+          <p:nvPr/>
         </p:nvPicPr>
         <p:blipFill>
           <a:blip r:embed="rId3">
@@ -14187,113 +14226,8 @@
         </p:blipFill>
         <p:spPr>
           <a:xfrm>
-            <a:off x="0" y="1374387"/>
-            <a:ext cx="6096000" cy="2770909"/>
-          </a:xfrm>
-        </p:spPr>
-      </p:pic>
-      <p:pic>
-        <p:nvPicPr>
-          <p:cNvPr id="27" name="Kép 26" descr="A képen szöveg, sor, Diagram, Betűtípus látható&#10;&#10;Automatikusan generált leírás">
-            <a:extLst>
-              <a:ext uri="{FF2B5EF4-FFF2-40B4-BE49-F238E27FC236}">
-                <a16:creationId xmlns:a16="http://schemas.microsoft.com/office/drawing/2014/main" id="{EFF63355-4441-C47C-C10A-AE24B3BE7656}"/>
-              </a:ext>
-            </a:extLst>
-          </p:cNvPr>
-          <p:cNvPicPr>
-            <a:picLocks noChangeAspect="1"/>
-          </p:cNvPicPr>
-          <p:nvPr/>
-        </p:nvPicPr>
-        <p:blipFill>
-          <a:blip r:embed="rId4">
-            <a:extLst>
-              <a:ext uri="{28A0092B-C50C-407E-A947-70E740481C1C}">
-                <a14:useLocalDpi xmlns:a14="http://schemas.microsoft.com/office/drawing/2010/main" val="0"/>
-              </a:ext>
-            </a:extLst>
-          </a:blip>
-          <a:stretch>
-            <a:fillRect/>
-          </a:stretch>
-        </p:blipFill>
-        <p:spPr>
-          <a:xfrm>
-            <a:off x="6096000" y="1374388"/>
-            <a:ext cx="6095999" cy="2770909"/>
-          </a:xfrm>
-          <a:prstGeom prst="rect">
-            <a:avLst/>
-          </a:prstGeom>
-        </p:spPr>
-      </p:pic>
-      <p:pic>
-        <p:nvPicPr>
-          <p:cNvPr id="29" name="Kép 28" descr="A képen szöveg, sor, képernyőkép, Diagram látható&#10;&#10;Automatikusan generált leírás">
-            <a:extLst>
-              <a:ext uri="{FF2B5EF4-FFF2-40B4-BE49-F238E27FC236}">
-                <a16:creationId xmlns:a16="http://schemas.microsoft.com/office/drawing/2014/main" id="{91F1A2F7-F0B7-6BCB-9E60-95C5091006FE}"/>
-              </a:ext>
-            </a:extLst>
-          </p:cNvPr>
-          <p:cNvPicPr>
-            <a:picLocks noChangeAspect="1"/>
-          </p:cNvPicPr>
-          <p:nvPr/>
-        </p:nvPicPr>
-        <p:blipFill>
-          <a:blip r:embed="rId5">
-            <a:extLst>
-              <a:ext uri="{28A0092B-C50C-407E-A947-70E740481C1C}">
-                <a14:useLocalDpi xmlns:a14="http://schemas.microsoft.com/office/drawing/2010/main" val="0"/>
-              </a:ext>
-            </a:extLst>
-          </a:blip>
-          <a:stretch>
-            <a:fillRect/>
-          </a:stretch>
-        </p:blipFill>
-        <p:spPr>
-          <a:xfrm>
-            <a:off x="-3600" y="3940106"/>
-            <a:ext cx="6098400" cy="2772000"/>
-          </a:xfrm>
-          <a:prstGeom prst="rect">
-            <a:avLst/>
-          </a:prstGeom>
-        </p:spPr>
-      </p:pic>
-      <p:pic>
-        <p:nvPicPr>
-          <p:cNvPr id="31" name="Kép 30" descr="A képen szöveg, sor, diagram, Diagram látható&#10;&#10;Automatikusan generált leírás">
-            <a:extLst>
-              <a:ext uri="{FF2B5EF4-FFF2-40B4-BE49-F238E27FC236}">
-                <a16:creationId xmlns:a16="http://schemas.microsoft.com/office/drawing/2014/main" id="{A271C484-B3A3-F8E7-CD05-349FDF08D31A}"/>
-              </a:ext>
-            </a:extLst>
-          </p:cNvPr>
-          <p:cNvPicPr>
-            <a:picLocks noChangeAspect="1"/>
-          </p:cNvPicPr>
-          <p:nvPr/>
-        </p:nvPicPr>
-        <p:blipFill>
-          <a:blip r:embed="rId6">
-            <a:extLst>
-              <a:ext uri="{28A0092B-C50C-407E-A947-70E740481C1C}">
-                <a14:useLocalDpi xmlns:a14="http://schemas.microsoft.com/office/drawing/2010/main" val="0"/>
-              </a:ext>
-            </a:extLst>
-          </a:blip>
-          <a:stretch>
-            <a:fillRect/>
-          </a:stretch>
-        </p:blipFill>
-        <p:spPr>
-          <a:xfrm>
-            <a:off x="6094800" y="4020641"/>
-            <a:ext cx="6098399" cy="2772000"/>
+            <a:off x="179614" y="1374388"/>
+            <a:ext cx="12012385" cy="5460176"/>
           </a:xfrm>
           <a:prstGeom prst="rect">
             <a:avLst/>
@@ -14335,6 +14269,963 @@
           <p:cNvPr id="2" name="Cím 1">
             <a:extLst>
               <a:ext uri="{FF2B5EF4-FFF2-40B4-BE49-F238E27FC236}">
+                <a16:creationId xmlns:a16="http://schemas.microsoft.com/office/drawing/2014/main" id="{E2CC6560-EBDE-281E-540B-F2359973FC55}"/>
+              </a:ext>
+            </a:extLst>
+          </p:cNvPr>
+          <p:cNvSpPr>
+            <a:spLocks noGrp="1"/>
+          </p:cNvSpPr>
+          <p:nvPr>
+            <p:ph type="title"/>
+          </p:nvPr>
+        </p:nvSpPr>
+        <p:spPr/>
+        <p:txBody>
+          <a:bodyPr/>
+          <a:lstStyle/>
+          <a:p>
+            <a:r>
+              <a:rPr lang="hu-HU" dirty="0"/>
+              <a:t>2. Kérdés</a:t>
+            </a:r>
+          </a:p>
+        </p:txBody>
+      </p:sp>
+      <p:sp>
+        <p:nvSpPr>
+          <p:cNvPr id="3" name="Tartalom helye 2">
+            <a:extLst>
+              <a:ext uri="{FF2B5EF4-FFF2-40B4-BE49-F238E27FC236}">
+                <a16:creationId xmlns:a16="http://schemas.microsoft.com/office/drawing/2014/main" id="{DEF847F5-DC62-8074-5FE4-7C47CB17BB8E}"/>
+              </a:ext>
+            </a:extLst>
+          </p:cNvPr>
+          <p:cNvSpPr>
+            <a:spLocks noGrp="1"/>
+          </p:cNvSpPr>
+          <p:nvPr>
+            <p:ph idx="1"/>
+          </p:nvPr>
+        </p:nvSpPr>
+        <p:spPr>
+          <a:xfrm>
+            <a:off x="838200" y="1825625"/>
+            <a:ext cx="10515600" cy="4901746"/>
+          </a:xfrm>
+        </p:spPr>
+        <p:txBody>
+          <a:bodyPr>
+            <a:normAutofit lnSpcReduction="10000"/>
+          </a:bodyPr>
+          <a:lstStyle/>
+          <a:p>
+            <a:pPr marL="0" indent="0">
+              <a:buNone/>
+            </a:pPr>
+            <a:r>
+              <a:rPr lang="hu-HU" dirty="0"/>
+              <a:t>„Milyen területeken jelenthet előnyt a kidolgozott Online </a:t>
+            </a:r>
+            <a:r>
+              <a:rPr lang="hu-HU" dirty="0" err="1"/>
+              <a:t>KMeans</a:t>
+            </a:r>
+            <a:r>
+              <a:rPr lang="hu-HU" dirty="0"/>
+              <a:t> algoritmus, illetve alkalmazás során milyen </a:t>
+            </a:r>
+            <a:r>
+              <a:rPr lang="hu-HU" dirty="0" err="1"/>
+              <a:t>limitációkat</a:t>
+            </a:r>
+            <a:r>
+              <a:rPr lang="hu-HU" dirty="0"/>
+              <a:t> érdemes szem előtt tartani?”</a:t>
+            </a:r>
+          </a:p>
+          <a:p>
+            <a:pPr marL="0" indent="0">
+              <a:buNone/>
+            </a:pPr>
+            <a:endParaRPr lang="hu-HU" dirty="0"/>
+          </a:p>
+          <a:p>
+            <a:pPr marL="0" indent="0">
+              <a:buNone/>
+            </a:pPr>
+            <a:r>
+              <a:rPr lang="hu-HU" dirty="0"/>
+              <a:t>Előnyök:</a:t>
+            </a:r>
+          </a:p>
+          <a:p>
+            <a:r>
+              <a:rPr lang="hu-HU" dirty="0"/>
+              <a:t>dinamikusan változó adathalmazok (pl.: valós idejű hírfolyam)</a:t>
+            </a:r>
+          </a:p>
+          <a:p>
+            <a:r>
+              <a:rPr lang="hu-HU" dirty="0"/>
+              <a:t>Adaptív struktúra (ha az adatok eloszlása időben változik)</a:t>
+            </a:r>
+          </a:p>
+          <a:p>
+            <a:pPr marL="0" indent="0">
+              <a:buNone/>
+            </a:pPr>
+            <a:r>
+              <a:rPr lang="hu-HU" dirty="0" err="1"/>
+              <a:t>Limitációk</a:t>
+            </a:r>
+            <a:r>
+              <a:rPr lang="hu-HU" dirty="0"/>
+              <a:t>:</a:t>
+            </a:r>
+          </a:p>
+          <a:p>
+            <a:r>
+              <a:rPr lang="hu-HU" dirty="0"/>
+              <a:t>Sorrendfüggőség: érzékeny az adatok sorrendjére</a:t>
+            </a:r>
+          </a:p>
+          <a:p>
+            <a:r>
+              <a:rPr lang="hu-HU" dirty="0"/>
+              <a:t>Paraméterérzékenység: „</a:t>
+            </a:r>
+            <a:r>
+              <a:rPr lang="hu-HU" dirty="0" err="1"/>
+              <a:t>new_cluster_threshold</a:t>
+            </a:r>
+            <a:r>
+              <a:rPr lang="hu-HU" dirty="0"/>
+              <a:t>”, „</a:t>
+            </a:r>
+            <a:r>
+              <a:rPr lang="hu-HU" dirty="0" err="1"/>
+              <a:t>merge_threshold</a:t>
+            </a:r>
+            <a:r>
+              <a:rPr lang="hu-HU" dirty="0"/>
+              <a:t>” helyes beállítása fontos</a:t>
+            </a:r>
+          </a:p>
+          <a:p>
+            <a:pPr marL="0" indent="0">
+              <a:buNone/>
+            </a:pPr>
+            <a:endParaRPr lang="hu-HU" dirty="0"/>
+          </a:p>
+          <a:p>
+            <a:pPr marL="0" indent="0">
+              <a:buNone/>
+            </a:pPr>
+            <a:endParaRPr lang="hu-HU" dirty="0"/>
+          </a:p>
+          <a:p>
+            <a:pPr marL="0" indent="0">
+              <a:buNone/>
+            </a:pPr>
+            <a:endParaRPr lang="hu-HU" dirty="0"/>
+          </a:p>
+          <a:p>
+            <a:pPr marL="0" indent="0">
+              <a:buNone/>
+            </a:pPr>
+            <a:endParaRPr lang="hu-HU" dirty="0"/>
+          </a:p>
+        </p:txBody>
+      </p:sp>
+    </p:spTree>
+    <p:extLst>
+      <p:ext uri="{BB962C8B-B14F-4D97-AF65-F5344CB8AC3E}">
+        <p14:creationId xmlns:p14="http://schemas.microsoft.com/office/powerpoint/2010/main" val="1039613238"/>
+      </p:ext>
+    </p:extLst>
+  </p:cSld>
+  <p:clrMapOvr>
+    <a:masterClrMapping/>
+  </p:clrMapOvr>
+</p:sld>
+</file>
+
+<file path=ppt/slides/slide26.xml><?xml version="1.0" encoding="utf-8"?>
+<p:sld xmlns:a="http://schemas.openxmlformats.org/drawingml/2006/main" xmlns:r="http://schemas.openxmlformats.org/officeDocument/2006/relationships" xmlns:p="http://schemas.openxmlformats.org/presentationml/2006/main">
+  <p:cSld>
+    <p:spTree>
+      <p:nvGrpSpPr>
+        <p:cNvPr id="1" name=""/>
+        <p:cNvGrpSpPr/>
+        <p:nvPr/>
+      </p:nvGrpSpPr>
+      <p:grpSpPr>
+        <a:xfrm>
+          <a:off x="0" y="0"/>
+          <a:ext cx="0" cy="0"/>
+          <a:chOff x="0" y="0"/>
+          <a:chExt cx="0" cy="0"/>
+        </a:xfrm>
+      </p:grpSpPr>
+      <p:sp>
+        <p:nvSpPr>
+          <p:cNvPr id="2" name="Cím 1">
+            <a:extLst>
+              <a:ext uri="{FF2B5EF4-FFF2-40B4-BE49-F238E27FC236}">
+                <a16:creationId xmlns:a16="http://schemas.microsoft.com/office/drawing/2014/main" id="{02242FBB-2962-2D0C-F440-AE52FF32F22D}"/>
+              </a:ext>
+            </a:extLst>
+          </p:cNvPr>
+          <p:cNvSpPr>
+            <a:spLocks noGrp="1"/>
+          </p:cNvSpPr>
+          <p:nvPr>
+            <p:ph type="title"/>
+          </p:nvPr>
+        </p:nvSpPr>
+        <p:spPr/>
+        <p:txBody>
+          <a:bodyPr/>
+          <a:lstStyle/>
+          <a:p>
+            <a:r>
+              <a:rPr lang="hu-HU" dirty="0"/>
+              <a:t>Forrásjegyzék</a:t>
+            </a:r>
+          </a:p>
+        </p:txBody>
+      </p:sp>
+      <p:sp>
+        <p:nvSpPr>
+          <p:cNvPr id="3" name="Tartalom helye 2">
+            <a:extLst>
+              <a:ext uri="{FF2B5EF4-FFF2-40B4-BE49-F238E27FC236}">
+                <a16:creationId xmlns:a16="http://schemas.microsoft.com/office/drawing/2014/main" id="{448F6325-171C-9526-86E2-566A20E5EABC}"/>
+              </a:ext>
+            </a:extLst>
+          </p:cNvPr>
+          <p:cNvSpPr>
+            <a:spLocks noGrp="1"/>
+          </p:cNvSpPr>
+          <p:nvPr>
+            <p:ph idx="1"/>
+          </p:nvPr>
+        </p:nvSpPr>
+        <p:spPr/>
+        <p:txBody>
+          <a:bodyPr>
+            <a:normAutofit/>
+          </a:bodyPr>
+          <a:lstStyle/>
+          <a:p>
+            <a:r>
+              <a:rPr lang="hu-HU" sz="1800" dirty="0"/>
+              <a:t>[1] </a:t>
+            </a:r>
+            <a:r>
+              <a:rPr lang="hu-HU" sz="1800" dirty="0" err="1"/>
+              <a:t>Hariom</a:t>
+            </a:r>
+            <a:r>
+              <a:rPr lang="hu-HU" sz="1800" dirty="0"/>
+              <a:t> </a:t>
+            </a:r>
+            <a:r>
+              <a:rPr lang="hu-HU" sz="1800" dirty="0" err="1"/>
+              <a:t>Gautam</a:t>
+            </a:r>
+            <a:r>
+              <a:rPr lang="hu-HU" sz="1800" dirty="0"/>
+              <a:t>, (2020.03.01.), Word </a:t>
+            </a:r>
+            <a:r>
+              <a:rPr lang="hu-HU" sz="1800" dirty="0" err="1"/>
+              <a:t>Embedding</a:t>
+            </a:r>
+            <a:r>
+              <a:rPr lang="hu-HU" sz="1800" dirty="0"/>
+              <a:t>: </a:t>
+            </a:r>
+            <a:r>
+              <a:rPr lang="hu-HU" sz="1800" dirty="0" err="1"/>
+              <a:t>Basics</a:t>
+            </a:r>
+            <a:r>
+              <a:rPr lang="hu-HU" sz="1800" dirty="0"/>
+              <a:t>, </a:t>
+            </a:r>
+            <a:r>
+              <a:rPr lang="hu-HU" sz="1800" dirty="0" err="1"/>
+              <a:t>Medium</a:t>
+            </a:r>
+            <a:r>
+              <a:rPr lang="hu-HU" sz="1800" dirty="0"/>
+              <a:t>, </a:t>
+            </a:r>
+            <a:r>
+              <a:rPr lang="hu-HU" sz="1800" dirty="0">
+                <a:hlinkClick r:id="rId3"/>
+              </a:rPr>
+              <a:t>https://medium.com/@hari4om/word-embedding-d816f643140</a:t>
+            </a:r>
+            <a:endParaRPr lang="hu-HU" sz="1800" dirty="0"/>
+          </a:p>
+          <a:p>
+            <a:r>
+              <a:rPr lang="hu-HU" sz="1800" dirty="0"/>
+              <a:t>[2] </a:t>
+            </a:r>
+            <a:r>
+              <a:rPr lang="hu-HU" sz="1800" dirty="0" err="1"/>
+              <a:t>Varun</a:t>
+            </a:r>
+            <a:r>
+              <a:rPr lang="hu-HU" sz="1800" dirty="0"/>
+              <a:t>, (2020.09.27.), </a:t>
+            </a:r>
+            <a:r>
+              <a:rPr lang="hu-HU" sz="1800" dirty="0" err="1"/>
+              <a:t>Cosine</a:t>
+            </a:r>
+            <a:r>
+              <a:rPr lang="hu-HU" sz="1800" dirty="0"/>
+              <a:t> </a:t>
+            </a:r>
+            <a:r>
+              <a:rPr lang="hu-HU" sz="1800" dirty="0" err="1"/>
+              <a:t>similarity</a:t>
+            </a:r>
+            <a:r>
+              <a:rPr lang="hu-HU" sz="1800" dirty="0"/>
+              <a:t>: </a:t>
+            </a:r>
+            <a:r>
+              <a:rPr lang="hu-HU" sz="1800" dirty="0" err="1"/>
+              <a:t>How</a:t>
+            </a:r>
+            <a:r>
+              <a:rPr lang="hu-HU" sz="1800" dirty="0"/>
+              <a:t> </a:t>
+            </a:r>
+            <a:r>
+              <a:rPr lang="hu-HU" sz="1800" dirty="0" err="1"/>
+              <a:t>does</a:t>
+            </a:r>
+            <a:r>
+              <a:rPr lang="hu-HU" sz="1800" dirty="0"/>
+              <a:t> </a:t>
+            </a:r>
+            <a:r>
+              <a:rPr lang="hu-HU" sz="1800" dirty="0" err="1"/>
+              <a:t>it</a:t>
+            </a:r>
+            <a:r>
+              <a:rPr lang="hu-HU" sz="1800" dirty="0"/>
+              <a:t> </a:t>
+            </a:r>
+            <a:r>
+              <a:rPr lang="hu-HU" sz="1800" dirty="0" err="1"/>
+              <a:t>measure</a:t>
+            </a:r>
+            <a:r>
+              <a:rPr lang="hu-HU" sz="1800" dirty="0"/>
+              <a:t> </a:t>
+            </a:r>
+            <a:r>
+              <a:rPr lang="hu-HU" sz="1800" dirty="0" err="1"/>
+              <a:t>the</a:t>
+            </a:r>
+            <a:r>
+              <a:rPr lang="hu-HU" sz="1800" dirty="0"/>
+              <a:t> </a:t>
+            </a:r>
+            <a:r>
+              <a:rPr lang="hu-HU" sz="1800" dirty="0" err="1"/>
+              <a:t>similarity</a:t>
+            </a:r>
+            <a:r>
+              <a:rPr lang="hu-HU" sz="1800" dirty="0"/>
+              <a:t>, </a:t>
+            </a:r>
+            <a:r>
+              <a:rPr lang="hu-HU" sz="1800" dirty="0" err="1"/>
+              <a:t>Maths</a:t>
+            </a:r>
+            <a:r>
+              <a:rPr lang="hu-HU" sz="1800" dirty="0"/>
+              <a:t> </a:t>
+            </a:r>
+            <a:r>
+              <a:rPr lang="hu-HU" sz="1800" dirty="0" err="1"/>
+              <a:t>behind</a:t>
+            </a:r>
+            <a:r>
+              <a:rPr lang="hu-HU" sz="1800" dirty="0"/>
+              <a:t> and </a:t>
+            </a:r>
+            <a:r>
+              <a:rPr lang="hu-HU" sz="1800" dirty="0" err="1"/>
+              <a:t>usage</a:t>
+            </a:r>
+            <a:r>
+              <a:rPr lang="hu-HU" sz="1800" dirty="0"/>
+              <a:t> in Python, towardsdatascience.com ,</a:t>
+            </a:r>
+            <a:r>
+              <a:rPr lang="hu-HU" sz="1800" dirty="0">
+                <a:hlinkClick r:id="rId4"/>
+              </a:rPr>
+              <a:t>https://towardsdatascience.com/cosine-similarity-how-does-it-measure-the-similarity-maths-behind-and-usage-in-python-50ad30aad7db/</a:t>
+            </a:r>
+            <a:endParaRPr lang="hu-HU" sz="1800" dirty="0"/>
+          </a:p>
+          <a:p>
+            <a:r>
+              <a:rPr lang="hu-HU" sz="1800" dirty="0"/>
+              <a:t>[3] </a:t>
+            </a:r>
+            <a:r>
+              <a:rPr lang="hu-HU" sz="1800" dirty="0" err="1">
+                <a:solidFill>
+                  <a:srgbClr val="000000"/>
+                </a:solidFill>
+                <a:effectLst/>
+              </a:rPr>
+              <a:t>Pranav</a:t>
+            </a:r>
+            <a:r>
+              <a:rPr lang="hu-HU" sz="1800" dirty="0">
+                <a:solidFill>
+                  <a:srgbClr val="000000"/>
+                </a:solidFill>
+                <a:effectLst/>
+              </a:rPr>
+              <a:t> </a:t>
+            </a:r>
+            <a:r>
+              <a:rPr lang="hu-HU" sz="1800" dirty="0" err="1">
+                <a:solidFill>
+                  <a:srgbClr val="000000"/>
+                </a:solidFill>
+                <a:effectLst/>
+              </a:rPr>
+              <a:t>Rajpurkar</a:t>
+            </a:r>
+            <a:r>
+              <a:rPr lang="hu-HU" sz="1800" dirty="0">
+                <a:solidFill>
+                  <a:srgbClr val="000000"/>
+                </a:solidFill>
+                <a:effectLst/>
+              </a:rPr>
+              <a:t>, </a:t>
+            </a:r>
+            <a:r>
+              <a:rPr lang="hu-HU" sz="1800" dirty="0" err="1">
+                <a:solidFill>
+                  <a:srgbClr val="000000"/>
+                </a:solidFill>
+                <a:effectLst/>
+              </a:rPr>
+              <a:t>Jian</a:t>
+            </a:r>
+            <a:r>
+              <a:rPr lang="hu-HU" sz="1800" dirty="0">
+                <a:solidFill>
+                  <a:srgbClr val="000000"/>
+                </a:solidFill>
+                <a:effectLst/>
+              </a:rPr>
+              <a:t> </a:t>
+            </a:r>
+            <a:r>
+              <a:rPr lang="hu-HU" sz="1800" dirty="0" err="1">
+                <a:solidFill>
+                  <a:srgbClr val="000000"/>
+                </a:solidFill>
+                <a:effectLst/>
+              </a:rPr>
+              <a:t>Zhang</a:t>
+            </a:r>
+            <a:r>
+              <a:rPr lang="hu-HU" sz="1800" dirty="0">
+                <a:solidFill>
+                  <a:srgbClr val="000000"/>
+                </a:solidFill>
+                <a:effectLst/>
+              </a:rPr>
+              <a:t>, </a:t>
+            </a:r>
+            <a:r>
+              <a:rPr lang="hu-HU" sz="1800" dirty="0">
+                <a:effectLst/>
+              </a:rPr>
+              <a:t>Konstantin</a:t>
+            </a:r>
+            <a:r>
+              <a:rPr lang="hu-HU" sz="1800" dirty="0">
+                <a:solidFill>
+                  <a:srgbClr val="000000"/>
+                </a:solidFill>
+                <a:effectLst/>
+              </a:rPr>
+              <a:t> </a:t>
+            </a:r>
+            <a:r>
+              <a:rPr lang="hu-HU" sz="1800" dirty="0" err="1">
+                <a:solidFill>
+                  <a:srgbClr val="000000"/>
+                </a:solidFill>
+                <a:effectLst/>
+              </a:rPr>
+              <a:t>Lopyrev</a:t>
+            </a:r>
+            <a:r>
+              <a:rPr lang="hu-HU" sz="1800" dirty="0">
+                <a:solidFill>
+                  <a:srgbClr val="000000"/>
+                </a:solidFill>
+                <a:effectLst/>
+              </a:rPr>
+              <a:t>, Percy </a:t>
+            </a:r>
+            <a:r>
+              <a:rPr lang="hu-HU" sz="1800" dirty="0" err="1">
+                <a:solidFill>
+                  <a:srgbClr val="000000"/>
+                </a:solidFill>
+                <a:effectLst/>
+              </a:rPr>
+              <a:t>Liang</a:t>
+            </a:r>
+            <a:r>
+              <a:rPr lang="hu-HU" sz="1800" dirty="0">
+                <a:solidFill>
+                  <a:srgbClr val="000000"/>
+                </a:solidFill>
+                <a:effectLst/>
+              </a:rPr>
+              <a:t>, (2016.06.16.),</a:t>
+            </a:r>
+            <a:r>
+              <a:rPr lang="hu-HU" sz="1800" dirty="0" err="1">
+                <a:solidFill>
+                  <a:srgbClr val="000000"/>
+                </a:solidFill>
+                <a:effectLst/>
+              </a:rPr>
+              <a:t>SQuAD</a:t>
+            </a:r>
+            <a:r>
+              <a:rPr lang="hu-HU" sz="1800" dirty="0">
+                <a:solidFill>
+                  <a:srgbClr val="000000"/>
+                </a:solidFill>
+                <a:effectLst/>
+              </a:rPr>
+              <a:t>:</a:t>
+            </a:r>
+          </a:p>
+          <a:p>
+            <a:r>
+              <a:rPr lang="hu-HU" sz="1800" dirty="0">
+                <a:solidFill>
+                  <a:srgbClr val="000000"/>
+                </a:solidFill>
+                <a:effectLst/>
+              </a:rPr>
+              <a:t>100,000+ </a:t>
+            </a:r>
+            <a:r>
+              <a:rPr lang="hu-HU" sz="1800" dirty="0" err="1">
+                <a:solidFill>
+                  <a:srgbClr val="000000"/>
+                </a:solidFill>
+                <a:effectLst/>
+              </a:rPr>
+              <a:t>Questions</a:t>
+            </a:r>
+            <a:r>
+              <a:rPr lang="hu-HU" sz="1800" dirty="0">
+                <a:solidFill>
+                  <a:srgbClr val="000000"/>
+                </a:solidFill>
+                <a:effectLst/>
+              </a:rPr>
+              <a:t> </a:t>
+            </a:r>
+            <a:r>
+              <a:rPr lang="hu-HU" sz="1800" dirty="0" err="1">
+                <a:solidFill>
+                  <a:srgbClr val="000000"/>
+                </a:solidFill>
+                <a:effectLst/>
+              </a:rPr>
+              <a:t>for</a:t>
+            </a:r>
+            <a:r>
+              <a:rPr lang="hu-HU" sz="1800" dirty="0">
+                <a:solidFill>
+                  <a:srgbClr val="000000"/>
+                </a:solidFill>
+                <a:effectLst/>
+              </a:rPr>
+              <a:t> </a:t>
+            </a:r>
+            <a:r>
+              <a:rPr lang="hu-HU" sz="1800" dirty="0" err="1">
+                <a:solidFill>
+                  <a:srgbClr val="000000"/>
+                </a:solidFill>
+                <a:effectLst/>
+              </a:rPr>
+              <a:t>Machine</a:t>
+            </a:r>
+            <a:r>
+              <a:rPr lang="hu-HU" sz="1800" dirty="0">
+                <a:solidFill>
+                  <a:srgbClr val="000000"/>
+                </a:solidFill>
+                <a:effectLst/>
+              </a:rPr>
+              <a:t> </a:t>
+            </a:r>
+            <a:r>
+              <a:rPr lang="hu-HU" sz="1800" dirty="0" err="1">
+                <a:solidFill>
+                  <a:srgbClr val="000000"/>
+                </a:solidFill>
+                <a:effectLst/>
+              </a:rPr>
+              <a:t>Comprehension</a:t>
+            </a:r>
+            <a:r>
+              <a:rPr lang="hu-HU" sz="1800" dirty="0">
+                <a:solidFill>
+                  <a:srgbClr val="000000"/>
+                </a:solidFill>
+                <a:effectLst/>
+              </a:rPr>
+              <a:t> of Text, </a:t>
+            </a:r>
+            <a:r>
+              <a:rPr lang="hu-HU" sz="1800" dirty="0" err="1">
+                <a:solidFill>
+                  <a:srgbClr val="000000"/>
+                </a:solidFill>
+                <a:effectLst/>
+              </a:rPr>
+              <a:t>ArXiv</a:t>
+            </a:r>
+            <a:r>
+              <a:rPr lang="hu-HU" sz="1800" dirty="0">
+                <a:solidFill>
+                  <a:srgbClr val="000000"/>
+                </a:solidFill>
+                <a:effectLst/>
+              </a:rPr>
+              <a:t>, </a:t>
+            </a:r>
+            <a:r>
+              <a:rPr lang="hu-HU" sz="1800" b="0" i="0" u="sng" dirty="0">
+                <a:effectLst/>
+                <a:hlinkClick r:id="rId5"/>
+              </a:rPr>
+              <a:t>https://doi.org/10.48550/arXiv.1606.05250</a:t>
+            </a:r>
+            <a:endParaRPr lang="hu-HU" sz="1800" dirty="0"/>
+          </a:p>
+          <a:p>
+            <a:endParaRPr lang="hu-HU" sz="2000" dirty="0"/>
+          </a:p>
+        </p:txBody>
+      </p:sp>
+      <p:sp>
+        <p:nvSpPr>
+          <p:cNvPr id="4" name="Dátum helye 3">
+            <a:extLst>
+              <a:ext uri="{FF2B5EF4-FFF2-40B4-BE49-F238E27FC236}">
+                <a16:creationId xmlns:a16="http://schemas.microsoft.com/office/drawing/2014/main" id="{E3AFDC56-C173-DBE4-4AB5-B1829C2CB1E8}"/>
+              </a:ext>
+            </a:extLst>
+          </p:cNvPr>
+          <p:cNvSpPr>
+            <a:spLocks noGrp="1"/>
+          </p:cNvSpPr>
+          <p:nvPr>
+            <p:ph type="dt" sz="half" idx="10"/>
+          </p:nvPr>
+        </p:nvSpPr>
+        <p:spPr/>
+        <p:txBody>
+          <a:bodyPr/>
+          <a:lstStyle/>
+          <a:p>
+            <a:endParaRPr lang="hu-HU" dirty="0"/>
+          </a:p>
+        </p:txBody>
+      </p:sp>
+      <p:sp>
+        <p:nvSpPr>
+          <p:cNvPr id="5" name="Dia számának helye 4">
+            <a:extLst>
+              <a:ext uri="{FF2B5EF4-FFF2-40B4-BE49-F238E27FC236}">
+                <a16:creationId xmlns:a16="http://schemas.microsoft.com/office/drawing/2014/main" id="{68737DFA-5AEE-8E85-0BBC-53632C2E9510}"/>
+              </a:ext>
+            </a:extLst>
+          </p:cNvPr>
+          <p:cNvSpPr>
+            <a:spLocks noGrp="1"/>
+          </p:cNvSpPr>
+          <p:nvPr>
+            <p:ph type="sldNum" sz="quarter" idx="12"/>
+          </p:nvPr>
+        </p:nvSpPr>
+        <p:spPr/>
+        <p:txBody>
+          <a:bodyPr/>
+          <a:lstStyle/>
+          <a:p>
+            <a:pPr marL="0" algn="l" defTabSz="914400" rtl="0" eaLnBrk="1" latinLnBrk="0" hangingPunct="1"/>
+            <a:endParaRPr lang="hu-HU" dirty="0"/>
+          </a:p>
+        </p:txBody>
+      </p:sp>
+    </p:spTree>
+    <p:extLst>
+      <p:ext uri="{BB962C8B-B14F-4D97-AF65-F5344CB8AC3E}">
+        <p14:creationId xmlns:p14="http://schemas.microsoft.com/office/powerpoint/2010/main" val="2015096485"/>
+      </p:ext>
+    </p:extLst>
+  </p:cSld>
+  <p:clrMapOvr>
+    <a:masterClrMapping/>
+  </p:clrMapOvr>
+</p:sld>
+</file>
+
+<file path=ppt/slides/slide27.xml><?xml version="1.0" encoding="utf-8"?>
+<p:sld xmlns:a="http://schemas.openxmlformats.org/drawingml/2006/main" xmlns:r="http://schemas.openxmlformats.org/officeDocument/2006/relationships" xmlns:p="http://schemas.openxmlformats.org/presentationml/2006/main">
+  <p:cSld>
+    <p:spTree>
+      <p:nvGrpSpPr>
+        <p:cNvPr id="1" name=""/>
+        <p:cNvGrpSpPr/>
+        <p:nvPr/>
+      </p:nvGrpSpPr>
+      <p:grpSpPr>
+        <a:xfrm>
+          <a:off x="0" y="0"/>
+          <a:ext cx="0" cy="0"/>
+          <a:chOff x="0" y="0"/>
+          <a:chExt cx="0" cy="0"/>
+        </a:xfrm>
+      </p:grpSpPr>
+      <p:sp>
+        <p:nvSpPr>
+          <p:cNvPr id="2" name="Cím 1">
+            <a:extLst>
+              <a:ext uri="{FF2B5EF4-FFF2-40B4-BE49-F238E27FC236}">
+                <a16:creationId xmlns:a16="http://schemas.microsoft.com/office/drawing/2014/main" id="{B26CACD5-0839-746C-3C67-C1AA05B09D92}"/>
+              </a:ext>
+            </a:extLst>
+          </p:cNvPr>
+          <p:cNvSpPr>
+            <a:spLocks noGrp="1"/>
+          </p:cNvSpPr>
+          <p:nvPr>
+            <p:ph type="title"/>
+          </p:nvPr>
+        </p:nvSpPr>
+        <p:spPr/>
+        <p:txBody>
+          <a:bodyPr/>
+          <a:lstStyle/>
+          <a:p>
+            <a:endParaRPr lang="hu-HU"/>
+          </a:p>
+        </p:txBody>
+      </p:sp>
+      <p:sp>
+        <p:nvSpPr>
+          <p:cNvPr id="3" name="Tartalom helye 2">
+            <a:extLst>
+              <a:ext uri="{FF2B5EF4-FFF2-40B4-BE49-F238E27FC236}">
+                <a16:creationId xmlns:a16="http://schemas.microsoft.com/office/drawing/2014/main" id="{F91C0FAF-2F53-46D2-66F4-BE60BB0ED3C2}"/>
+              </a:ext>
+            </a:extLst>
+          </p:cNvPr>
+          <p:cNvSpPr>
+            <a:spLocks noGrp="1"/>
+          </p:cNvSpPr>
+          <p:nvPr>
+            <p:ph idx="1"/>
+          </p:nvPr>
+        </p:nvSpPr>
+        <p:spPr/>
+        <p:txBody>
+          <a:bodyPr/>
+          <a:lstStyle/>
+          <a:p>
+            <a:r>
+              <a:rPr lang="hu-HU" dirty="0" err="1"/>
+              <a:t>Delete</a:t>
+            </a:r>
+            <a:r>
+              <a:rPr lang="hu-HU" dirty="0"/>
+              <a:t> </a:t>
+            </a:r>
+            <a:r>
+              <a:rPr lang="hu-HU" dirty="0" err="1"/>
+              <a:t>from</a:t>
+            </a:r>
+            <a:r>
+              <a:rPr lang="hu-HU" dirty="0"/>
+              <a:t> here</a:t>
+            </a:r>
+          </a:p>
+        </p:txBody>
+      </p:sp>
+      <p:sp>
+        <p:nvSpPr>
+          <p:cNvPr id="4" name="Dátum helye 3">
+            <a:extLst>
+              <a:ext uri="{FF2B5EF4-FFF2-40B4-BE49-F238E27FC236}">
+                <a16:creationId xmlns:a16="http://schemas.microsoft.com/office/drawing/2014/main" id="{9B92409B-7AA0-55D4-B20E-3BD396DAF644}"/>
+              </a:ext>
+            </a:extLst>
+          </p:cNvPr>
+          <p:cNvSpPr>
+            <a:spLocks noGrp="1"/>
+          </p:cNvSpPr>
+          <p:nvPr>
+            <p:ph type="dt" sz="half" idx="10"/>
+          </p:nvPr>
+        </p:nvSpPr>
+        <p:spPr/>
+        <p:txBody>
+          <a:bodyPr/>
+          <a:lstStyle/>
+          <a:p>
+            <a:fld id="{FB2979DB-241A-8544-95D6-5A5515E861C2}" type="datetime1">
+              <a:rPr lang="hu-HU" smtClean="0"/>
+              <a:t>2026. 01. 05.</a:t>
+            </a:fld>
+            <a:endParaRPr lang="hu-HU"/>
+          </a:p>
+        </p:txBody>
+      </p:sp>
+      <p:sp>
+        <p:nvSpPr>
+          <p:cNvPr id="5" name="Dia számának helye 4">
+            <a:extLst>
+              <a:ext uri="{FF2B5EF4-FFF2-40B4-BE49-F238E27FC236}">
+                <a16:creationId xmlns:a16="http://schemas.microsoft.com/office/drawing/2014/main" id="{E12DECB5-6B54-654D-A65F-8A9605FB3814}"/>
+              </a:ext>
+            </a:extLst>
+          </p:cNvPr>
+          <p:cNvSpPr>
+            <a:spLocks noGrp="1"/>
+          </p:cNvSpPr>
+          <p:nvPr>
+            <p:ph type="sldNum" sz="quarter" idx="12"/>
+          </p:nvPr>
+        </p:nvSpPr>
+        <p:spPr/>
+        <p:txBody>
+          <a:bodyPr/>
+          <a:lstStyle/>
+          <a:p>
+            <a:fld id="{61F88ADF-3301-4598-B089-C6A4CC92BE83}" type="slidenum">
+              <a:rPr lang="hu-HU" smtClean="0"/>
+              <a:t>27</a:t>
+            </a:fld>
+            <a:endParaRPr lang="hu-HU"/>
+          </a:p>
+        </p:txBody>
+      </p:sp>
+      <p:sp>
+        <p:nvSpPr>
+          <p:cNvPr id="8" name="Lefelé mutató nyíl 7">
+            <a:extLst>
+              <a:ext uri="{FF2B5EF4-FFF2-40B4-BE49-F238E27FC236}">
+                <a16:creationId xmlns:a16="http://schemas.microsoft.com/office/drawing/2014/main" id="{D76F25A7-11C4-AC6F-3159-0D6BCC22CEE2}"/>
+              </a:ext>
+            </a:extLst>
+          </p:cNvPr>
+          <p:cNvSpPr/>
+          <p:nvPr/>
+        </p:nvSpPr>
+        <p:spPr>
+          <a:xfrm>
+            <a:off x="2612571" y="2841171"/>
+            <a:ext cx="1877786" cy="2677886"/>
+          </a:xfrm>
+          <a:prstGeom prst="downArrow">
+            <a:avLst/>
+          </a:prstGeom>
+        </p:spPr>
+        <p:style>
+          <a:lnRef idx="2">
+            <a:schemeClr val="accent1">
+              <a:shade val="15000"/>
+            </a:schemeClr>
+          </a:lnRef>
+          <a:fillRef idx="1">
+            <a:schemeClr val="accent1"/>
+          </a:fillRef>
+          <a:effectRef idx="0">
+            <a:schemeClr val="accent1"/>
+          </a:effectRef>
+          <a:fontRef idx="minor">
+            <a:schemeClr val="lt1"/>
+          </a:fontRef>
+        </p:style>
+        <p:txBody>
+          <a:bodyPr rtlCol="0" anchor="ctr"/>
+          <a:lstStyle/>
+          <a:p>
+            <a:pPr algn="ctr"/>
+            <a:endParaRPr lang="hu-HU"/>
+          </a:p>
+        </p:txBody>
+      </p:sp>
+    </p:spTree>
+    <p:extLst>
+      <p:ext uri="{BB962C8B-B14F-4D97-AF65-F5344CB8AC3E}">
+        <p14:creationId xmlns:p14="http://schemas.microsoft.com/office/powerpoint/2010/main" val="4146380522"/>
+      </p:ext>
+    </p:extLst>
+  </p:cSld>
+  <p:clrMapOvr>
+    <a:masterClrMapping/>
+  </p:clrMapOvr>
+</p:sld>
+</file>
+
+<file path=ppt/slides/slide28.xml><?xml version="1.0" encoding="utf-8"?>
+<p:sld xmlns:a="http://schemas.openxmlformats.org/drawingml/2006/main" xmlns:r="http://schemas.openxmlformats.org/officeDocument/2006/relationships" xmlns:p="http://schemas.openxmlformats.org/presentationml/2006/main">
+  <p:cSld>
+    <p:spTree>
+      <p:nvGrpSpPr>
+        <p:cNvPr id="1" name=""/>
+        <p:cNvGrpSpPr/>
+        <p:nvPr/>
+      </p:nvGrpSpPr>
+      <p:grpSpPr>
+        <a:xfrm>
+          <a:off x="0" y="0"/>
+          <a:ext cx="0" cy="0"/>
+          <a:chOff x="0" y="0"/>
+          <a:chExt cx="0" cy="0"/>
+        </a:xfrm>
+      </p:grpSpPr>
+      <p:sp>
+        <p:nvSpPr>
+          <p:cNvPr id="2" name="Cím 1">
+            <a:extLst>
+              <a:ext uri="{FF2B5EF4-FFF2-40B4-BE49-F238E27FC236}">
                 <a16:creationId xmlns:a16="http://schemas.microsoft.com/office/drawing/2014/main" id="{A5C2D948-E810-3B60-6951-A5D022A784E3}"/>
               </a:ext>
             </a:extLst>
@@ -14523,7 +15414,7 @@
 </p:sld>
 </file>
 
-<file path=ppt/slides/slide26.xml><?xml version="1.0" encoding="utf-8"?>
+<file path=ppt/slides/slide29.xml><?xml version="1.0" encoding="utf-8"?>
 <p:sld xmlns:a="http://schemas.openxmlformats.org/drawingml/2006/main" xmlns:r="http://schemas.openxmlformats.org/officeDocument/2006/relationships" xmlns:p="http://schemas.openxmlformats.org/presentationml/2006/main">
   <p:cSld>
     <p:spTree>
@@ -14778,571 +15669,6 @@
 </p:sld>
 </file>
 
-<file path=ppt/slides/slide27.xml><?xml version="1.0" encoding="utf-8"?>
-<p:sld xmlns:a="http://schemas.openxmlformats.org/drawingml/2006/main" xmlns:r="http://schemas.openxmlformats.org/officeDocument/2006/relationships" xmlns:p="http://schemas.openxmlformats.org/presentationml/2006/main">
-  <p:cSld>
-    <p:spTree>
-      <p:nvGrpSpPr>
-        <p:cNvPr id="1" name=""/>
-        <p:cNvGrpSpPr/>
-        <p:nvPr/>
-      </p:nvGrpSpPr>
-      <p:grpSpPr>
-        <a:xfrm>
-          <a:off x="0" y="0"/>
-          <a:ext cx="0" cy="0"/>
-          <a:chOff x="0" y="0"/>
-          <a:chExt cx="0" cy="0"/>
-        </a:xfrm>
-      </p:grpSpPr>
-      <p:sp>
-        <p:nvSpPr>
-          <p:cNvPr id="2" name="Cím 1">
-            <a:extLst>
-              <a:ext uri="{FF2B5EF4-FFF2-40B4-BE49-F238E27FC236}">
-                <a16:creationId xmlns:a16="http://schemas.microsoft.com/office/drawing/2014/main" id="{AFFD2839-A558-CE58-D988-2A70BB3D814C}"/>
-              </a:ext>
-            </a:extLst>
-          </p:cNvPr>
-          <p:cNvSpPr>
-            <a:spLocks noGrp="1"/>
-          </p:cNvSpPr>
-          <p:nvPr>
-            <p:ph type="title"/>
-          </p:nvPr>
-        </p:nvSpPr>
-        <p:spPr/>
-        <p:txBody>
-          <a:bodyPr/>
-          <a:lstStyle/>
-          <a:p>
-            <a:r>
-              <a:rPr lang="hu-HU" dirty="0"/>
-              <a:t>1. Bíráló – 3/3 kérdés</a:t>
-            </a:r>
-          </a:p>
-        </p:txBody>
-      </p:sp>
-      <p:sp>
-        <p:nvSpPr>
-          <p:cNvPr id="3" name="Tartalom helye 2">
-            <a:extLst>
-              <a:ext uri="{FF2B5EF4-FFF2-40B4-BE49-F238E27FC236}">
-                <a16:creationId xmlns:a16="http://schemas.microsoft.com/office/drawing/2014/main" id="{61CBE8E2-710D-D873-97C2-3629D7B4CA21}"/>
-              </a:ext>
-            </a:extLst>
-          </p:cNvPr>
-          <p:cNvSpPr>
-            <a:spLocks noGrp="1"/>
-          </p:cNvSpPr>
-          <p:nvPr>
-            <p:ph idx="1"/>
-          </p:nvPr>
-        </p:nvSpPr>
-        <p:spPr/>
-        <p:txBody>
-          <a:bodyPr>
-            <a:normAutofit fontScale="92500" lnSpcReduction="20000"/>
-          </a:bodyPr>
-          <a:lstStyle/>
-          <a:p>
-            <a:r>
-              <a:rPr lang="hu-HU" dirty="0"/>
-              <a:t>A kísérleteiben a javasolt </a:t>
-            </a:r>
-            <a:r>
-              <a:rPr lang="hu-HU" dirty="0" err="1"/>
-              <a:t>klaszterezés</a:t>
-            </a:r>
-            <a:r>
-              <a:rPr lang="hu-HU" dirty="0"/>
-              <a:t>-alapú módszerek a minőség rovására javítanak a hatékonyságon a szokásos kereséshez képest. Tudja-e esetleg konkretizálni, hogy milyen alkalmazások, vagy szcenáriók esetén érné meg inkább a </a:t>
-            </a:r>
-            <a:r>
-              <a:rPr lang="hu-HU" dirty="0" err="1"/>
-              <a:t>klaszterezést</a:t>
-            </a:r>
-            <a:r>
-              <a:rPr lang="hu-HU" dirty="0"/>
-              <a:t> használni a bevett módszerekkel szemben?</a:t>
-            </a:r>
-          </a:p>
-          <a:p>
-            <a:endParaRPr lang="hu-HU" dirty="0"/>
-          </a:p>
-          <a:p>
-            <a:pPr marL="0" indent="0">
-              <a:buNone/>
-            </a:pPr>
-            <a:r>
-              <a:rPr lang="hu-HU" dirty="0"/>
-              <a:t>Válasz:</a:t>
-            </a:r>
-          </a:p>
-          <a:p>
-            <a:pPr marL="0" indent="0">
-              <a:buNone/>
-            </a:pPr>
-            <a:r>
-              <a:rPr lang="hu-HU" dirty="0"/>
-              <a:t>Olyan dinamikusan változó tudásbázisok esetén, ahol az új információk témája előre nem látható módon és gyorsan változik, a rendszernek pedig valós időben kell integrálni az új adatokat.</a:t>
-            </a:r>
-          </a:p>
-          <a:p>
-            <a:r>
-              <a:rPr lang="hu-HU" dirty="0"/>
-              <a:t>Valós idejű híráram és közösségi média</a:t>
-            </a:r>
-          </a:p>
-          <a:p>
-            <a:r>
-              <a:rPr lang="hu-HU" dirty="0"/>
-              <a:t>Élő ügyfélszolgálat chatbot</a:t>
-            </a:r>
-          </a:p>
-        </p:txBody>
-      </p:sp>
-      <p:sp>
-        <p:nvSpPr>
-          <p:cNvPr id="4" name="Dátum helye 3">
-            <a:extLst>
-              <a:ext uri="{FF2B5EF4-FFF2-40B4-BE49-F238E27FC236}">
-                <a16:creationId xmlns:a16="http://schemas.microsoft.com/office/drawing/2014/main" id="{72380C67-3C45-D763-3973-7ED6B3540198}"/>
-              </a:ext>
-            </a:extLst>
-          </p:cNvPr>
-          <p:cNvSpPr>
-            <a:spLocks noGrp="1"/>
-          </p:cNvSpPr>
-          <p:nvPr>
-            <p:ph type="dt" sz="half" idx="10"/>
-          </p:nvPr>
-        </p:nvSpPr>
-        <p:spPr/>
-        <p:txBody>
-          <a:bodyPr/>
-          <a:lstStyle/>
-          <a:p>
-            <a:endParaRPr lang="hu-HU" dirty="0"/>
-          </a:p>
-        </p:txBody>
-      </p:sp>
-    </p:spTree>
-    <p:extLst>
-      <p:ext uri="{BB962C8B-B14F-4D97-AF65-F5344CB8AC3E}">
-        <p14:creationId xmlns:p14="http://schemas.microsoft.com/office/powerpoint/2010/main" val="4241420566"/>
-      </p:ext>
-    </p:extLst>
-  </p:cSld>
-  <p:clrMapOvr>
-    <a:masterClrMapping/>
-  </p:clrMapOvr>
-</p:sld>
-</file>
-
-<file path=ppt/slides/slide28.xml><?xml version="1.0" encoding="utf-8"?>
-<p:sld xmlns:a="http://schemas.openxmlformats.org/drawingml/2006/main" xmlns:r="http://schemas.openxmlformats.org/officeDocument/2006/relationships" xmlns:p="http://schemas.openxmlformats.org/presentationml/2006/main">
-  <p:cSld>
-    <p:spTree>
-      <p:nvGrpSpPr>
-        <p:cNvPr id="1" name=""/>
-        <p:cNvGrpSpPr/>
-        <p:nvPr/>
-      </p:nvGrpSpPr>
-      <p:grpSpPr>
-        <a:xfrm>
-          <a:off x="0" y="0"/>
-          <a:ext cx="0" cy="0"/>
-          <a:chOff x="0" y="0"/>
-          <a:chExt cx="0" cy="0"/>
-        </a:xfrm>
-      </p:grpSpPr>
-      <p:sp>
-        <p:nvSpPr>
-          <p:cNvPr id="2" name="Cím 1">
-            <a:extLst>
-              <a:ext uri="{FF2B5EF4-FFF2-40B4-BE49-F238E27FC236}">
-                <a16:creationId xmlns:a16="http://schemas.microsoft.com/office/drawing/2014/main" id="{2B3D404A-3302-6578-2D67-2C24E0F733CF}"/>
-              </a:ext>
-            </a:extLst>
-          </p:cNvPr>
-          <p:cNvSpPr>
-            <a:spLocks noGrp="1"/>
-          </p:cNvSpPr>
-          <p:nvPr>
-            <p:ph type="title"/>
-          </p:nvPr>
-        </p:nvSpPr>
-        <p:spPr/>
-        <p:txBody>
-          <a:bodyPr/>
-          <a:lstStyle/>
-          <a:p>
-            <a:r>
-              <a:rPr lang="hu-HU" dirty="0"/>
-              <a:t>2. Bíráló – 1/3 kérdés</a:t>
-            </a:r>
-          </a:p>
-        </p:txBody>
-      </p:sp>
-      <p:sp>
-        <p:nvSpPr>
-          <p:cNvPr id="3" name="Tartalom helye 2">
-            <a:extLst>
-              <a:ext uri="{FF2B5EF4-FFF2-40B4-BE49-F238E27FC236}">
-                <a16:creationId xmlns:a16="http://schemas.microsoft.com/office/drawing/2014/main" id="{1420C507-EB27-3FCF-ED99-D04A0F081CBC}"/>
-              </a:ext>
-            </a:extLst>
-          </p:cNvPr>
-          <p:cNvSpPr>
-            <a:spLocks noGrp="1"/>
-          </p:cNvSpPr>
-          <p:nvPr>
-            <p:ph idx="1"/>
-          </p:nvPr>
-        </p:nvSpPr>
-        <p:spPr>
-          <a:xfrm>
-            <a:off x="838200" y="1524000"/>
-            <a:ext cx="10515600" cy="4652963"/>
-          </a:xfrm>
-        </p:spPr>
-        <p:txBody>
-          <a:bodyPr>
-            <a:normAutofit fontScale="92500" lnSpcReduction="10000"/>
-          </a:bodyPr>
-          <a:lstStyle/>
-          <a:p>
-            <a:r>
-              <a:rPr lang="hu-HU" dirty="0"/>
-              <a:t>Hogyan kapcsolódik a bevezetett klaszter alapú, két lépcsős dokumentum keresés a FAISS könyvtárba tartozó IVF indexelési módszerhez?</a:t>
-            </a:r>
-          </a:p>
-          <a:p>
-            <a:endParaRPr lang="hu-HU" dirty="0"/>
-          </a:p>
-          <a:p>
-            <a:pPr marL="0" indent="0">
-              <a:buNone/>
-            </a:pPr>
-            <a:r>
-              <a:rPr lang="hu-HU" dirty="0"/>
-              <a:t>Válasz:</a:t>
-            </a:r>
-          </a:p>
-          <a:p>
-            <a:pPr marL="0" indent="0">
-              <a:buNone/>
-            </a:pPr>
-            <a:r>
-              <a:rPr lang="hu-HU" dirty="0"/>
-              <a:t>A kutatásom célja a dinamikus, streaming környezetek hatékony kezelése volt. FAISS IVF </a:t>
-            </a:r>
-            <a:r>
-              <a:rPr lang="hu-HU" dirty="0" err="1"/>
-              <a:t>KMeans</a:t>
-            </a:r>
-            <a:r>
-              <a:rPr lang="hu-HU" dirty="0"/>
-              <a:t> </a:t>
-            </a:r>
-            <a:r>
-              <a:rPr lang="hu-HU" dirty="0" err="1"/>
-              <a:t>klaszterezésen</a:t>
-            </a:r>
-            <a:r>
-              <a:rPr lang="hu-HU" dirty="0"/>
-              <a:t> alapszik, koncepcionálisan hasonlít az én módszeremre, de nem képes új klasztereket létrehozni, és meglévőket módosítani. Azért a HNSW alapú FAISS indexet választottam kiértékeléskor, mert képes gyorsan integrálni új adatokat, miközben a gráf struktúráját is változtatja. Az IVF-ben új pontok ugyan hozzáadhatók, de a klaszterstruktúra csak </a:t>
-            </a:r>
-            <a:r>
-              <a:rPr lang="hu-HU" dirty="0" err="1"/>
-              <a:t>újratanítással</a:t>
-            </a:r>
-            <a:r>
-              <a:rPr lang="hu-HU" dirty="0"/>
-              <a:t> frissíthető, </a:t>
-            </a:r>
-            <a:r>
-              <a:rPr lang="hu-HU" dirty="0" err="1"/>
-              <a:t>centroidjai</a:t>
-            </a:r>
-            <a:r>
-              <a:rPr lang="hu-HU" dirty="0"/>
-              <a:t> statikusak.</a:t>
-            </a:r>
-          </a:p>
-        </p:txBody>
-      </p:sp>
-      <p:sp>
-        <p:nvSpPr>
-          <p:cNvPr id="4" name="Dátum helye 3">
-            <a:extLst>
-              <a:ext uri="{FF2B5EF4-FFF2-40B4-BE49-F238E27FC236}">
-                <a16:creationId xmlns:a16="http://schemas.microsoft.com/office/drawing/2014/main" id="{36C9FEC2-180B-7E5C-D40A-C4B2BEC1B6C2}"/>
-              </a:ext>
-            </a:extLst>
-          </p:cNvPr>
-          <p:cNvSpPr>
-            <a:spLocks noGrp="1"/>
-          </p:cNvSpPr>
-          <p:nvPr>
-            <p:ph type="dt" sz="half" idx="10"/>
-          </p:nvPr>
-        </p:nvSpPr>
-        <p:spPr/>
-        <p:txBody>
-          <a:bodyPr/>
-          <a:lstStyle/>
-          <a:p>
-            <a:endParaRPr lang="hu-HU" dirty="0"/>
-          </a:p>
-        </p:txBody>
-      </p:sp>
-      <p:sp>
-        <p:nvSpPr>
-          <p:cNvPr id="5" name="Dia számának helye 4">
-            <a:extLst>
-              <a:ext uri="{FF2B5EF4-FFF2-40B4-BE49-F238E27FC236}">
-                <a16:creationId xmlns:a16="http://schemas.microsoft.com/office/drawing/2014/main" id="{4F5D90A3-581C-D439-01FA-2812B87D907E}"/>
-              </a:ext>
-            </a:extLst>
-          </p:cNvPr>
-          <p:cNvSpPr>
-            <a:spLocks noGrp="1"/>
-          </p:cNvSpPr>
-          <p:nvPr>
-            <p:ph type="sldNum" sz="quarter" idx="12"/>
-          </p:nvPr>
-        </p:nvSpPr>
-        <p:spPr/>
-        <p:txBody>
-          <a:bodyPr/>
-          <a:lstStyle/>
-          <a:p>
-            <a:endParaRPr lang="hu-HU" dirty="0"/>
-          </a:p>
-        </p:txBody>
-      </p:sp>
-    </p:spTree>
-    <p:extLst>
-      <p:ext uri="{BB962C8B-B14F-4D97-AF65-F5344CB8AC3E}">
-        <p14:creationId xmlns:p14="http://schemas.microsoft.com/office/powerpoint/2010/main" val="1218943555"/>
-      </p:ext>
-    </p:extLst>
-  </p:cSld>
-  <p:clrMapOvr>
-    <a:masterClrMapping/>
-  </p:clrMapOvr>
-</p:sld>
-</file>
-
-<file path=ppt/slides/slide29.xml><?xml version="1.0" encoding="utf-8"?>
-<p:sld xmlns:a="http://schemas.openxmlformats.org/drawingml/2006/main" xmlns:r="http://schemas.openxmlformats.org/officeDocument/2006/relationships" xmlns:p="http://schemas.openxmlformats.org/presentationml/2006/main">
-  <p:cSld>
-    <p:spTree>
-      <p:nvGrpSpPr>
-        <p:cNvPr id="1" name=""/>
-        <p:cNvGrpSpPr/>
-        <p:nvPr/>
-      </p:nvGrpSpPr>
-      <p:grpSpPr>
-        <a:xfrm>
-          <a:off x="0" y="0"/>
-          <a:ext cx="0" cy="0"/>
-          <a:chOff x="0" y="0"/>
-          <a:chExt cx="0" cy="0"/>
-        </a:xfrm>
-      </p:grpSpPr>
-      <p:sp>
-        <p:nvSpPr>
-          <p:cNvPr id="2" name="Cím 1">
-            <a:extLst>
-              <a:ext uri="{FF2B5EF4-FFF2-40B4-BE49-F238E27FC236}">
-                <a16:creationId xmlns:a16="http://schemas.microsoft.com/office/drawing/2014/main" id="{50A6FD8F-0EC8-FA24-9871-53A30DCF9897}"/>
-              </a:ext>
-            </a:extLst>
-          </p:cNvPr>
-          <p:cNvSpPr>
-            <a:spLocks noGrp="1"/>
-          </p:cNvSpPr>
-          <p:nvPr>
-            <p:ph type="title"/>
-          </p:nvPr>
-        </p:nvSpPr>
-        <p:spPr/>
-        <p:txBody>
-          <a:bodyPr/>
-          <a:lstStyle/>
-          <a:p>
-            <a:r>
-              <a:rPr lang="hu-HU" dirty="0"/>
-              <a:t>2. Bíráló – 2/3 kérdés</a:t>
-            </a:r>
-            <a:br>
-              <a:rPr lang="hu-HU" dirty="0"/>
-            </a:br>
-            <a:endParaRPr lang="hu-HU" dirty="0"/>
-          </a:p>
-        </p:txBody>
-      </p:sp>
-      <p:sp>
-        <p:nvSpPr>
-          <p:cNvPr id="3" name="Tartalom helye 2">
-            <a:extLst>
-              <a:ext uri="{FF2B5EF4-FFF2-40B4-BE49-F238E27FC236}">
-                <a16:creationId xmlns:a16="http://schemas.microsoft.com/office/drawing/2014/main" id="{339949F5-1AC9-199E-3E98-BD1808EDE719}"/>
-              </a:ext>
-            </a:extLst>
-          </p:cNvPr>
-          <p:cNvSpPr>
-            <a:spLocks noGrp="1"/>
-          </p:cNvSpPr>
-          <p:nvPr>
-            <p:ph idx="1"/>
-          </p:nvPr>
-        </p:nvSpPr>
-        <p:spPr>
-          <a:xfrm>
-            <a:off x="838200" y="1436158"/>
-            <a:ext cx="10515600" cy="4351338"/>
-          </a:xfrm>
-        </p:spPr>
-        <p:txBody>
-          <a:bodyPr>
-            <a:normAutofit fontScale="85000" lnSpcReduction="20000"/>
-          </a:bodyPr>
-          <a:lstStyle/>
-          <a:p>
-            <a:r>
-              <a:rPr lang="hu-HU" dirty="0"/>
-              <a:t>Az Online </a:t>
-            </a:r>
-            <a:r>
-              <a:rPr lang="hu-HU" dirty="0" err="1"/>
-              <a:t>KMeans</a:t>
-            </a:r>
-            <a:r>
-              <a:rPr lang="hu-HU" dirty="0"/>
-              <a:t> algoritmus küszöbértékeket tartalmaz a klaszterek összevonására és új klaszter bevezetésére. Milyen módszerrel lettek ezek az értékek kiválasztva, és milyen hatása van a túl alacsony vagy túl magas értéknek a rendszer stabilitására?</a:t>
-            </a:r>
-          </a:p>
-          <a:p>
-            <a:endParaRPr lang="hu-HU" dirty="0"/>
-          </a:p>
-          <a:p>
-            <a:pPr marL="0" indent="0">
-              <a:buNone/>
-            </a:pPr>
-            <a:r>
-              <a:rPr lang="hu-HU" dirty="0"/>
-              <a:t>Válasz:</a:t>
-            </a:r>
-          </a:p>
-          <a:p>
-            <a:r>
-              <a:rPr lang="hu-HU" dirty="0"/>
-              <a:t>A küszöbértékeket az adathalmaz elemzése alapján választottam meg, és az adott környezethez kell hangolni őket.</a:t>
-            </a:r>
-          </a:p>
-          <a:p>
-            <a:pPr>
-              <a:buFont typeface="Arial" panose="020B0604020202020204" pitchFamily="34" charset="0"/>
-              <a:buChar char="•"/>
-            </a:pPr>
-            <a:r>
-              <a:rPr lang="hu-HU" b="1" dirty="0"/>
-              <a:t>Összevonási küszöbérték:</a:t>
-            </a:r>
-            <a:br>
-              <a:rPr lang="hu-HU" dirty="0"/>
-            </a:br>
-            <a:r>
-              <a:rPr lang="hu-HU" dirty="0"/>
-              <a:t>Túl alacsony értéknél nem vonódnak össze a klaszterek, túl magasnál szinte mind összeolvad.</a:t>
-            </a:r>
-          </a:p>
-          <a:p>
-            <a:pPr>
-              <a:buFont typeface="Arial" panose="020B0604020202020204" pitchFamily="34" charset="0"/>
-              <a:buChar char="•"/>
-            </a:pPr>
-            <a:r>
-              <a:rPr lang="hu-HU" b="1" dirty="0"/>
-              <a:t>Új klaszter küszöbérték:</a:t>
-            </a:r>
-            <a:br>
-              <a:rPr lang="hu-HU" dirty="0"/>
-            </a:br>
-            <a:r>
-              <a:rPr lang="hu-HU" dirty="0"/>
-              <a:t>Túl magas értéknél nem keletkeznek új klaszterek, túl alacsonynál túl sok jön létre.</a:t>
-            </a:r>
-          </a:p>
-        </p:txBody>
-      </p:sp>
-      <p:sp>
-        <p:nvSpPr>
-          <p:cNvPr id="4" name="Dátum helye 3">
-            <a:extLst>
-              <a:ext uri="{FF2B5EF4-FFF2-40B4-BE49-F238E27FC236}">
-                <a16:creationId xmlns:a16="http://schemas.microsoft.com/office/drawing/2014/main" id="{47213920-9C0B-904B-7D21-4B7673C7448A}"/>
-              </a:ext>
-            </a:extLst>
-          </p:cNvPr>
-          <p:cNvSpPr>
-            <a:spLocks noGrp="1"/>
-          </p:cNvSpPr>
-          <p:nvPr>
-            <p:ph type="dt" sz="half" idx="10"/>
-          </p:nvPr>
-        </p:nvSpPr>
-        <p:spPr/>
-        <p:txBody>
-          <a:bodyPr/>
-          <a:lstStyle/>
-          <a:p>
-            <a:endParaRPr lang="hu-HU" dirty="0"/>
-          </a:p>
-        </p:txBody>
-      </p:sp>
-      <p:sp>
-        <p:nvSpPr>
-          <p:cNvPr id="5" name="Dia számának helye 4">
-            <a:extLst>
-              <a:ext uri="{FF2B5EF4-FFF2-40B4-BE49-F238E27FC236}">
-                <a16:creationId xmlns:a16="http://schemas.microsoft.com/office/drawing/2014/main" id="{A866DA96-D6F4-97A7-6DB9-E4B1BE207529}"/>
-              </a:ext>
-            </a:extLst>
-          </p:cNvPr>
-          <p:cNvSpPr>
-            <a:spLocks noGrp="1"/>
-          </p:cNvSpPr>
-          <p:nvPr>
-            <p:ph type="sldNum" sz="quarter" idx="12"/>
-          </p:nvPr>
-        </p:nvSpPr>
-        <p:spPr/>
-        <p:txBody>
-          <a:bodyPr/>
-          <a:lstStyle/>
-          <a:p>
-            <a:endParaRPr lang="hu-HU" dirty="0"/>
-          </a:p>
-        </p:txBody>
-      </p:sp>
-    </p:spTree>
-    <p:extLst>
-      <p:ext uri="{BB962C8B-B14F-4D97-AF65-F5344CB8AC3E}">
-        <p14:creationId xmlns:p14="http://schemas.microsoft.com/office/powerpoint/2010/main" val="1862809591"/>
-      </p:ext>
-    </p:extLst>
-  </p:cSld>
-  <p:clrMapOvr>
-    <a:masterClrMapping/>
-  </p:clrMapOvr>
-</p:sld>
-</file>
-
 <file path=ppt/slides/slide3.xml><?xml version="1.0" encoding="utf-8"?>
 <p:sld xmlns:a="http://schemas.openxmlformats.org/drawingml/2006/main" xmlns:r="http://schemas.openxmlformats.org/officeDocument/2006/relationships" xmlns:p="http://schemas.openxmlformats.org/presentationml/2006/main">
   <p:cSld>
@@ -15479,7 +15805,7 @@
           <a:p>
             <a:fld id="{FB2979DB-241A-8544-95D6-5A5515E861C2}" type="datetime1">
               <a:rPr lang="hu-HU" smtClean="0"/>
-              <a:t>2025. 12. 28.</a:t>
+              <a:t>2026. 01. 05.</a:t>
             </a:fld>
             <a:endParaRPr lang="hu-HU"/>
           </a:p>
@@ -15588,6 +15914,571 @@
           <p:cNvPr id="2" name="Cím 1">
             <a:extLst>
               <a:ext uri="{FF2B5EF4-FFF2-40B4-BE49-F238E27FC236}">
+                <a16:creationId xmlns:a16="http://schemas.microsoft.com/office/drawing/2014/main" id="{AFFD2839-A558-CE58-D988-2A70BB3D814C}"/>
+              </a:ext>
+            </a:extLst>
+          </p:cNvPr>
+          <p:cNvSpPr>
+            <a:spLocks noGrp="1"/>
+          </p:cNvSpPr>
+          <p:nvPr>
+            <p:ph type="title"/>
+          </p:nvPr>
+        </p:nvSpPr>
+        <p:spPr/>
+        <p:txBody>
+          <a:bodyPr/>
+          <a:lstStyle/>
+          <a:p>
+            <a:r>
+              <a:rPr lang="hu-HU" dirty="0"/>
+              <a:t>1. Bíráló – 3/3 kérdés</a:t>
+            </a:r>
+          </a:p>
+        </p:txBody>
+      </p:sp>
+      <p:sp>
+        <p:nvSpPr>
+          <p:cNvPr id="3" name="Tartalom helye 2">
+            <a:extLst>
+              <a:ext uri="{FF2B5EF4-FFF2-40B4-BE49-F238E27FC236}">
+                <a16:creationId xmlns:a16="http://schemas.microsoft.com/office/drawing/2014/main" id="{61CBE8E2-710D-D873-97C2-3629D7B4CA21}"/>
+              </a:ext>
+            </a:extLst>
+          </p:cNvPr>
+          <p:cNvSpPr>
+            <a:spLocks noGrp="1"/>
+          </p:cNvSpPr>
+          <p:nvPr>
+            <p:ph idx="1"/>
+          </p:nvPr>
+        </p:nvSpPr>
+        <p:spPr/>
+        <p:txBody>
+          <a:bodyPr>
+            <a:normAutofit fontScale="92500" lnSpcReduction="20000"/>
+          </a:bodyPr>
+          <a:lstStyle/>
+          <a:p>
+            <a:r>
+              <a:rPr lang="hu-HU" dirty="0"/>
+              <a:t>A kísérleteiben a javasolt </a:t>
+            </a:r>
+            <a:r>
+              <a:rPr lang="hu-HU" dirty="0" err="1"/>
+              <a:t>klaszterezés</a:t>
+            </a:r>
+            <a:r>
+              <a:rPr lang="hu-HU" dirty="0"/>
+              <a:t>-alapú módszerek a minőség rovására javítanak a hatékonyságon a szokásos kereséshez képest. Tudja-e esetleg konkretizálni, hogy milyen alkalmazások, vagy szcenáriók esetén érné meg inkább a </a:t>
+            </a:r>
+            <a:r>
+              <a:rPr lang="hu-HU" dirty="0" err="1"/>
+              <a:t>klaszterezést</a:t>
+            </a:r>
+            <a:r>
+              <a:rPr lang="hu-HU" dirty="0"/>
+              <a:t> használni a bevett módszerekkel szemben?</a:t>
+            </a:r>
+          </a:p>
+          <a:p>
+            <a:endParaRPr lang="hu-HU" dirty="0"/>
+          </a:p>
+          <a:p>
+            <a:pPr marL="0" indent="0">
+              <a:buNone/>
+            </a:pPr>
+            <a:r>
+              <a:rPr lang="hu-HU" dirty="0"/>
+              <a:t>Válasz:</a:t>
+            </a:r>
+          </a:p>
+          <a:p>
+            <a:pPr marL="0" indent="0">
+              <a:buNone/>
+            </a:pPr>
+            <a:r>
+              <a:rPr lang="hu-HU" dirty="0"/>
+              <a:t>Olyan dinamikusan változó tudásbázisok esetén, ahol az új információk témája előre nem látható módon és gyorsan változik, a rendszernek pedig valós időben kell integrálni az új adatokat.</a:t>
+            </a:r>
+          </a:p>
+          <a:p>
+            <a:r>
+              <a:rPr lang="hu-HU" dirty="0"/>
+              <a:t>Valós idejű híráram és közösségi média</a:t>
+            </a:r>
+          </a:p>
+          <a:p>
+            <a:r>
+              <a:rPr lang="hu-HU" dirty="0"/>
+              <a:t>Élő ügyfélszolgálat chatbot</a:t>
+            </a:r>
+          </a:p>
+        </p:txBody>
+      </p:sp>
+      <p:sp>
+        <p:nvSpPr>
+          <p:cNvPr id="4" name="Dátum helye 3">
+            <a:extLst>
+              <a:ext uri="{FF2B5EF4-FFF2-40B4-BE49-F238E27FC236}">
+                <a16:creationId xmlns:a16="http://schemas.microsoft.com/office/drawing/2014/main" id="{72380C67-3C45-D763-3973-7ED6B3540198}"/>
+              </a:ext>
+            </a:extLst>
+          </p:cNvPr>
+          <p:cNvSpPr>
+            <a:spLocks noGrp="1"/>
+          </p:cNvSpPr>
+          <p:nvPr>
+            <p:ph type="dt" sz="half" idx="10"/>
+          </p:nvPr>
+        </p:nvSpPr>
+        <p:spPr/>
+        <p:txBody>
+          <a:bodyPr/>
+          <a:lstStyle/>
+          <a:p>
+            <a:endParaRPr lang="hu-HU" dirty="0"/>
+          </a:p>
+        </p:txBody>
+      </p:sp>
+    </p:spTree>
+    <p:extLst>
+      <p:ext uri="{BB962C8B-B14F-4D97-AF65-F5344CB8AC3E}">
+        <p14:creationId xmlns:p14="http://schemas.microsoft.com/office/powerpoint/2010/main" val="4241420566"/>
+      </p:ext>
+    </p:extLst>
+  </p:cSld>
+  <p:clrMapOvr>
+    <a:masterClrMapping/>
+  </p:clrMapOvr>
+</p:sld>
+</file>
+
+<file path=ppt/slides/slide31.xml><?xml version="1.0" encoding="utf-8"?>
+<p:sld xmlns:a="http://schemas.openxmlformats.org/drawingml/2006/main" xmlns:r="http://schemas.openxmlformats.org/officeDocument/2006/relationships" xmlns:p="http://schemas.openxmlformats.org/presentationml/2006/main">
+  <p:cSld>
+    <p:spTree>
+      <p:nvGrpSpPr>
+        <p:cNvPr id="1" name=""/>
+        <p:cNvGrpSpPr/>
+        <p:nvPr/>
+      </p:nvGrpSpPr>
+      <p:grpSpPr>
+        <a:xfrm>
+          <a:off x="0" y="0"/>
+          <a:ext cx="0" cy="0"/>
+          <a:chOff x="0" y="0"/>
+          <a:chExt cx="0" cy="0"/>
+        </a:xfrm>
+      </p:grpSpPr>
+      <p:sp>
+        <p:nvSpPr>
+          <p:cNvPr id="2" name="Cím 1">
+            <a:extLst>
+              <a:ext uri="{FF2B5EF4-FFF2-40B4-BE49-F238E27FC236}">
+                <a16:creationId xmlns:a16="http://schemas.microsoft.com/office/drawing/2014/main" id="{2B3D404A-3302-6578-2D67-2C24E0F733CF}"/>
+              </a:ext>
+            </a:extLst>
+          </p:cNvPr>
+          <p:cNvSpPr>
+            <a:spLocks noGrp="1"/>
+          </p:cNvSpPr>
+          <p:nvPr>
+            <p:ph type="title"/>
+          </p:nvPr>
+        </p:nvSpPr>
+        <p:spPr/>
+        <p:txBody>
+          <a:bodyPr/>
+          <a:lstStyle/>
+          <a:p>
+            <a:r>
+              <a:rPr lang="hu-HU" dirty="0"/>
+              <a:t>2. Bíráló – 1/3 kérdés</a:t>
+            </a:r>
+          </a:p>
+        </p:txBody>
+      </p:sp>
+      <p:sp>
+        <p:nvSpPr>
+          <p:cNvPr id="3" name="Tartalom helye 2">
+            <a:extLst>
+              <a:ext uri="{FF2B5EF4-FFF2-40B4-BE49-F238E27FC236}">
+                <a16:creationId xmlns:a16="http://schemas.microsoft.com/office/drawing/2014/main" id="{1420C507-EB27-3FCF-ED99-D04A0F081CBC}"/>
+              </a:ext>
+            </a:extLst>
+          </p:cNvPr>
+          <p:cNvSpPr>
+            <a:spLocks noGrp="1"/>
+          </p:cNvSpPr>
+          <p:nvPr>
+            <p:ph idx="1"/>
+          </p:nvPr>
+        </p:nvSpPr>
+        <p:spPr>
+          <a:xfrm>
+            <a:off x="838200" y="1524000"/>
+            <a:ext cx="10515600" cy="4652963"/>
+          </a:xfrm>
+        </p:spPr>
+        <p:txBody>
+          <a:bodyPr>
+            <a:normAutofit fontScale="92500" lnSpcReduction="10000"/>
+          </a:bodyPr>
+          <a:lstStyle/>
+          <a:p>
+            <a:r>
+              <a:rPr lang="hu-HU" dirty="0"/>
+              <a:t>Hogyan kapcsolódik a bevezetett klaszter alapú, két lépcsős dokumentum keresés a FAISS könyvtárba tartozó IVF indexelési módszerhez?</a:t>
+            </a:r>
+          </a:p>
+          <a:p>
+            <a:endParaRPr lang="hu-HU" dirty="0"/>
+          </a:p>
+          <a:p>
+            <a:pPr marL="0" indent="0">
+              <a:buNone/>
+            </a:pPr>
+            <a:r>
+              <a:rPr lang="hu-HU" dirty="0"/>
+              <a:t>Válasz:</a:t>
+            </a:r>
+          </a:p>
+          <a:p>
+            <a:pPr marL="0" indent="0">
+              <a:buNone/>
+            </a:pPr>
+            <a:r>
+              <a:rPr lang="hu-HU" dirty="0"/>
+              <a:t>A kutatásom célja a dinamikus, streaming környezetek hatékony kezelése volt. FAISS IVF </a:t>
+            </a:r>
+            <a:r>
+              <a:rPr lang="hu-HU" dirty="0" err="1"/>
+              <a:t>KMeans</a:t>
+            </a:r>
+            <a:r>
+              <a:rPr lang="hu-HU" dirty="0"/>
+              <a:t> </a:t>
+            </a:r>
+            <a:r>
+              <a:rPr lang="hu-HU" dirty="0" err="1"/>
+              <a:t>klaszterezésen</a:t>
+            </a:r>
+            <a:r>
+              <a:rPr lang="hu-HU" dirty="0"/>
+              <a:t> alapszik, koncepcionálisan hasonlít az én módszeremre, de nem képes új klasztereket létrehozni, és meglévőket módosítani. Azért a HNSW alapú FAISS indexet választottam kiértékeléskor, mert képes gyorsan integrálni új adatokat, miközben a gráf struktúráját is változtatja. Az IVF-ben új pontok ugyan hozzáadhatók, de a klaszterstruktúra csak </a:t>
+            </a:r>
+            <a:r>
+              <a:rPr lang="hu-HU" dirty="0" err="1"/>
+              <a:t>újratanítással</a:t>
+            </a:r>
+            <a:r>
+              <a:rPr lang="hu-HU" dirty="0"/>
+              <a:t> frissíthető, </a:t>
+            </a:r>
+            <a:r>
+              <a:rPr lang="hu-HU" dirty="0" err="1"/>
+              <a:t>centroidjai</a:t>
+            </a:r>
+            <a:r>
+              <a:rPr lang="hu-HU" dirty="0"/>
+              <a:t> statikusak.</a:t>
+            </a:r>
+          </a:p>
+        </p:txBody>
+      </p:sp>
+      <p:sp>
+        <p:nvSpPr>
+          <p:cNvPr id="4" name="Dátum helye 3">
+            <a:extLst>
+              <a:ext uri="{FF2B5EF4-FFF2-40B4-BE49-F238E27FC236}">
+                <a16:creationId xmlns:a16="http://schemas.microsoft.com/office/drawing/2014/main" id="{36C9FEC2-180B-7E5C-D40A-C4B2BEC1B6C2}"/>
+              </a:ext>
+            </a:extLst>
+          </p:cNvPr>
+          <p:cNvSpPr>
+            <a:spLocks noGrp="1"/>
+          </p:cNvSpPr>
+          <p:nvPr>
+            <p:ph type="dt" sz="half" idx="10"/>
+          </p:nvPr>
+        </p:nvSpPr>
+        <p:spPr/>
+        <p:txBody>
+          <a:bodyPr/>
+          <a:lstStyle/>
+          <a:p>
+            <a:endParaRPr lang="hu-HU" dirty="0"/>
+          </a:p>
+        </p:txBody>
+      </p:sp>
+      <p:sp>
+        <p:nvSpPr>
+          <p:cNvPr id="5" name="Dia számának helye 4">
+            <a:extLst>
+              <a:ext uri="{FF2B5EF4-FFF2-40B4-BE49-F238E27FC236}">
+                <a16:creationId xmlns:a16="http://schemas.microsoft.com/office/drawing/2014/main" id="{4F5D90A3-581C-D439-01FA-2812B87D907E}"/>
+              </a:ext>
+            </a:extLst>
+          </p:cNvPr>
+          <p:cNvSpPr>
+            <a:spLocks noGrp="1"/>
+          </p:cNvSpPr>
+          <p:nvPr>
+            <p:ph type="sldNum" sz="quarter" idx="12"/>
+          </p:nvPr>
+        </p:nvSpPr>
+        <p:spPr/>
+        <p:txBody>
+          <a:bodyPr/>
+          <a:lstStyle/>
+          <a:p>
+            <a:endParaRPr lang="hu-HU" dirty="0"/>
+          </a:p>
+        </p:txBody>
+      </p:sp>
+    </p:spTree>
+    <p:extLst>
+      <p:ext uri="{BB962C8B-B14F-4D97-AF65-F5344CB8AC3E}">
+        <p14:creationId xmlns:p14="http://schemas.microsoft.com/office/powerpoint/2010/main" val="1218943555"/>
+      </p:ext>
+    </p:extLst>
+  </p:cSld>
+  <p:clrMapOvr>
+    <a:masterClrMapping/>
+  </p:clrMapOvr>
+</p:sld>
+</file>
+
+<file path=ppt/slides/slide32.xml><?xml version="1.0" encoding="utf-8"?>
+<p:sld xmlns:a="http://schemas.openxmlformats.org/drawingml/2006/main" xmlns:r="http://schemas.openxmlformats.org/officeDocument/2006/relationships" xmlns:p="http://schemas.openxmlformats.org/presentationml/2006/main">
+  <p:cSld>
+    <p:spTree>
+      <p:nvGrpSpPr>
+        <p:cNvPr id="1" name=""/>
+        <p:cNvGrpSpPr/>
+        <p:nvPr/>
+      </p:nvGrpSpPr>
+      <p:grpSpPr>
+        <a:xfrm>
+          <a:off x="0" y="0"/>
+          <a:ext cx="0" cy="0"/>
+          <a:chOff x="0" y="0"/>
+          <a:chExt cx="0" cy="0"/>
+        </a:xfrm>
+      </p:grpSpPr>
+      <p:sp>
+        <p:nvSpPr>
+          <p:cNvPr id="2" name="Cím 1">
+            <a:extLst>
+              <a:ext uri="{FF2B5EF4-FFF2-40B4-BE49-F238E27FC236}">
+                <a16:creationId xmlns:a16="http://schemas.microsoft.com/office/drawing/2014/main" id="{50A6FD8F-0EC8-FA24-9871-53A30DCF9897}"/>
+              </a:ext>
+            </a:extLst>
+          </p:cNvPr>
+          <p:cNvSpPr>
+            <a:spLocks noGrp="1"/>
+          </p:cNvSpPr>
+          <p:nvPr>
+            <p:ph type="title"/>
+          </p:nvPr>
+        </p:nvSpPr>
+        <p:spPr/>
+        <p:txBody>
+          <a:bodyPr/>
+          <a:lstStyle/>
+          <a:p>
+            <a:r>
+              <a:rPr lang="hu-HU" dirty="0"/>
+              <a:t>2. Bíráló – 2/3 kérdés</a:t>
+            </a:r>
+            <a:br>
+              <a:rPr lang="hu-HU" dirty="0"/>
+            </a:br>
+            <a:endParaRPr lang="hu-HU" dirty="0"/>
+          </a:p>
+        </p:txBody>
+      </p:sp>
+      <p:sp>
+        <p:nvSpPr>
+          <p:cNvPr id="3" name="Tartalom helye 2">
+            <a:extLst>
+              <a:ext uri="{FF2B5EF4-FFF2-40B4-BE49-F238E27FC236}">
+                <a16:creationId xmlns:a16="http://schemas.microsoft.com/office/drawing/2014/main" id="{339949F5-1AC9-199E-3E98-BD1808EDE719}"/>
+              </a:ext>
+            </a:extLst>
+          </p:cNvPr>
+          <p:cNvSpPr>
+            <a:spLocks noGrp="1"/>
+          </p:cNvSpPr>
+          <p:nvPr>
+            <p:ph idx="1"/>
+          </p:nvPr>
+        </p:nvSpPr>
+        <p:spPr>
+          <a:xfrm>
+            <a:off x="838200" y="1436158"/>
+            <a:ext cx="10515600" cy="4351338"/>
+          </a:xfrm>
+        </p:spPr>
+        <p:txBody>
+          <a:bodyPr>
+            <a:normAutofit fontScale="85000" lnSpcReduction="20000"/>
+          </a:bodyPr>
+          <a:lstStyle/>
+          <a:p>
+            <a:r>
+              <a:rPr lang="hu-HU" dirty="0"/>
+              <a:t>Az Online </a:t>
+            </a:r>
+            <a:r>
+              <a:rPr lang="hu-HU" dirty="0" err="1"/>
+              <a:t>KMeans</a:t>
+            </a:r>
+            <a:r>
+              <a:rPr lang="hu-HU" dirty="0"/>
+              <a:t> algoritmus küszöbértékeket tartalmaz a klaszterek összevonására és új klaszter bevezetésére. Milyen módszerrel lettek ezek az értékek kiválasztva, és milyen hatása van a túl alacsony vagy túl magas értéknek a rendszer stabilitására?</a:t>
+            </a:r>
+          </a:p>
+          <a:p>
+            <a:endParaRPr lang="hu-HU" dirty="0"/>
+          </a:p>
+          <a:p>
+            <a:pPr marL="0" indent="0">
+              <a:buNone/>
+            </a:pPr>
+            <a:r>
+              <a:rPr lang="hu-HU" dirty="0"/>
+              <a:t>Válasz:</a:t>
+            </a:r>
+          </a:p>
+          <a:p>
+            <a:r>
+              <a:rPr lang="hu-HU" dirty="0"/>
+              <a:t>A küszöbértékeket az adathalmaz elemzése alapján választottam meg, és az adott környezethez kell hangolni őket.</a:t>
+            </a:r>
+          </a:p>
+          <a:p>
+            <a:pPr>
+              <a:buFont typeface="Arial" panose="020B0604020202020204" pitchFamily="34" charset="0"/>
+              <a:buChar char="•"/>
+            </a:pPr>
+            <a:r>
+              <a:rPr lang="hu-HU" b="1" dirty="0"/>
+              <a:t>Összevonási küszöbérték:</a:t>
+            </a:r>
+            <a:br>
+              <a:rPr lang="hu-HU" dirty="0"/>
+            </a:br>
+            <a:r>
+              <a:rPr lang="hu-HU" dirty="0"/>
+              <a:t>Túl alacsony értéknél nem vonódnak össze a klaszterek, túl magasnál szinte mind összeolvad.</a:t>
+            </a:r>
+          </a:p>
+          <a:p>
+            <a:pPr>
+              <a:buFont typeface="Arial" panose="020B0604020202020204" pitchFamily="34" charset="0"/>
+              <a:buChar char="•"/>
+            </a:pPr>
+            <a:r>
+              <a:rPr lang="hu-HU" b="1" dirty="0"/>
+              <a:t>Új klaszter küszöbérték:</a:t>
+            </a:r>
+            <a:br>
+              <a:rPr lang="hu-HU" dirty="0"/>
+            </a:br>
+            <a:r>
+              <a:rPr lang="hu-HU" dirty="0"/>
+              <a:t>Túl magas értéknél nem keletkeznek új klaszterek, túl alacsonynál túl sok jön létre.</a:t>
+            </a:r>
+          </a:p>
+        </p:txBody>
+      </p:sp>
+      <p:sp>
+        <p:nvSpPr>
+          <p:cNvPr id="4" name="Dátum helye 3">
+            <a:extLst>
+              <a:ext uri="{FF2B5EF4-FFF2-40B4-BE49-F238E27FC236}">
+                <a16:creationId xmlns:a16="http://schemas.microsoft.com/office/drawing/2014/main" id="{47213920-9C0B-904B-7D21-4B7673C7448A}"/>
+              </a:ext>
+            </a:extLst>
+          </p:cNvPr>
+          <p:cNvSpPr>
+            <a:spLocks noGrp="1"/>
+          </p:cNvSpPr>
+          <p:nvPr>
+            <p:ph type="dt" sz="half" idx="10"/>
+          </p:nvPr>
+        </p:nvSpPr>
+        <p:spPr/>
+        <p:txBody>
+          <a:bodyPr/>
+          <a:lstStyle/>
+          <a:p>
+            <a:endParaRPr lang="hu-HU" dirty="0"/>
+          </a:p>
+        </p:txBody>
+      </p:sp>
+      <p:sp>
+        <p:nvSpPr>
+          <p:cNvPr id="5" name="Dia számának helye 4">
+            <a:extLst>
+              <a:ext uri="{FF2B5EF4-FFF2-40B4-BE49-F238E27FC236}">
+                <a16:creationId xmlns:a16="http://schemas.microsoft.com/office/drawing/2014/main" id="{A866DA96-D6F4-97A7-6DB9-E4B1BE207529}"/>
+              </a:ext>
+            </a:extLst>
+          </p:cNvPr>
+          <p:cNvSpPr>
+            <a:spLocks noGrp="1"/>
+          </p:cNvSpPr>
+          <p:nvPr>
+            <p:ph type="sldNum" sz="quarter" idx="12"/>
+          </p:nvPr>
+        </p:nvSpPr>
+        <p:spPr/>
+        <p:txBody>
+          <a:bodyPr/>
+          <a:lstStyle/>
+          <a:p>
+            <a:endParaRPr lang="hu-HU" dirty="0"/>
+          </a:p>
+        </p:txBody>
+      </p:sp>
+    </p:spTree>
+    <p:extLst>
+      <p:ext uri="{BB962C8B-B14F-4D97-AF65-F5344CB8AC3E}">
+        <p14:creationId xmlns:p14="http://schemas.microsoft.com/office/powerpoint/2010/main" val="1862809591"/>
+      </p:ext>
+    </p:extLst>
+  </p:cSld>
+  <p:clrMapOvr>
+    <a:masterClrMapping/>
+  </p:clrMapOvr>
+</p:sld>
+</file>
+
+<file path=ppt/slides/slide33.xml><?xml version="1.0" encoding="utf-8"?>
+<p:sld xmlns:a="http://schemas.openxmlformats.org/drawingml/2006/main" xmlns:r="http://schemas.openxmlformats.org/officeDocument/2006/relationships" xmlns:p="http://schemas.openxmlformats.org/presentationml/2006/main">
+  <p:cSld>
+    <p:spTree>
+      <p:nvGrpSpPr>
+        <p:cNvPr id="1" name=""/>
+        <p:cNvGrpSpPr/>
+        <p:nvPr/>
+      </p:nvGrpSpPr>
+      <p:grpSpPr>
+        <a:xfrm>
+          <a:off x="0" y="0"/>
+          <a:ext cx="0" cy="0"/>
+          <a:chOff x="0" y="0"/>
+          <a:chExt cx="0" cy="0"/>
+        </a:xfrm>
+      </p:grpSpPr>
+      <p:sp>
+        <p:nvSpPr>
+          <p:cNvPr id="2" name="Cím 1">
+            <a:extLst>
+              <a:ext uri="{FF2B5EF4-FFF2-40B4-BE49-F238E27FC236}">
                 <a16:creationId xmlns:a16="http://schemas.microsoft.com/office/drawing/2014/main" id="{91BAD43B-D426-7CBC-3AE6-E58FABDB8A36}"/>
               </a:ext>
             </a:extLst>
@@ -16207,560 +17098,6 @@
     <p:extLst>
       <p:ext uri="{BB962C8B-B14F-4D97-AF65-F5344CB8AC3E}">
         <p14:creationId xmlns:p14="http://schemas.microsoft.com/office/powerpoint/2010/main" val="3886749342"/>
-      </p:ext>
-    </p:extLst>
-  </p:cSld>
-  <p:clrMapOvr>
-    <a:masterClrMapping/>
-  </p:clrMapOvr>
-</p:sld>
-</file>
-
-<file path=ppt/slides/slide31.xml><?xml version="1.0" encoding="utf-8"?>
-<p:sld xmlns:a="http://schemas.openxmlformats.org/drawingml/2006/main" xmlns:r="http://schemas.openxmlformats.org/officeDocument/2006/relationships" xmlns:p="http://schemas.openxmlformats.org/presentationml/2006/main">
-  <p:cSld>
-    <p:spTree>
-      <p:nvGrpSpPr>
-        <p:cNvPr id="1" name=""/>
-        <p:cNvGrpSpPr/>
-        <p:nvPr/>
-      </p:nvGrpSpPr>
-      <p:grpSpPr>
-        <a:xfrm>
-          <a:off x="0" y="0"/>
-          <a:ext cx="0" cy="0"/>
-          <a:chOff x="0" y="0"/>
-          <a:chExt cx="0" cy="0"/>
-        </a:xfrm>
-      </p:grpSpPr>
-      <p:sp>
-        <p:nvSpPr>
-          <p:cNvPr id="2" name="Cím 1">
-            <a:extLst>
-              <a:ext uri="{FF2B5EF4-FFF2-40B4-BE49-F238E27FC236}">
-                <a16:creationId xmlns:a16="http://schemas.microsoft.com/office/drawing/2014/main" id="{02242FBB-2962-2D0C-F440-AE52FF32F22D}"/>
-              </a:ext>
-            </a:extLst>
-          </p:cNvPr>
-          <p:cNvSpPr>
-            <a:spLocks noGrp="1"/>
-          </p:cNvSpPr>
-          <p:nvPr>
-            <p:ph type="title"/>
-          </p:nvPr>
-        </p:nvSpPr>
-        <p:spPr/>
-        <p:txBody>
-          <a:bodyPr/>
-          <a:lstStyle/>
-          <a:p>
-            <a:r>
-              <a:rPr lang="hu-HU" dirty="0"/>
-              <a:t>Forrásjegyzék</a:t>
-            </a:r>
-          </a:p>
-        </p:txBody>
-      </p:sp>
-      <p:sp>
-        <p:nvSpPr>
-          <p:cNvPr id="3" name="Tartalom helye 2">
-            <a:extLst>
-              <a:ext uri="{FF2B5EF4-FFF2-40B4-BE49-F238E27FC236}">
-                <a16:creationId xmlns:a16="http://schemas.microsoft.com/office/drawing/2014/main" id="{448F6325-171C-9526-86E2-566A20E5EABC}"/>
-              </a:ext>
-            </a:extLst>
-          </p:cNvPr>
-          <p:cNvSpPr>
-            <a:spLocks noGrp="1"/>
-          </p:cNvSpPr>
-          <p:nvPr>
-            <p:ph idx="1"/>
-          </p:nvPr>
-        </p:nvSpPr>
-        <p:spPr/>
-        <p:txBody>
-          <a:bodyPr>
-            <a:normAutofit/>
-          </a:bodyPr>
-          <a:lstStyle/>
-          <a:p>
-            <a:r>
-              <a:rPr lang="hu-HU" sz="1800" dirty="0"/>
-              <a:t>[1] </a:t>
-            </a:r>
-            <a:r>
-              <a:rPr lang="hu-HU" sz="1800" dirty="0" err="1"/>
-              <a:t>Hariom</a:t>
-            </a:r>
-            <a:r>
-              <a:rPr lang="hu-HU" sz="1800" dirty="0"/>
-              <a:t> </a:t>
-            </a:r>
-            <a:r>
-              <a:rPr lang="hu-HU" sz="1800" dirty="0" err="1"/>
-              <a:t>Gautam</a:t>
-            </a:r>
-            <a:r>
-              <a:rPr lang="hu-HU" sz="1800" dirty="0"/>
-              <a:t>, (2020.03.01.), Word </a:t>
-            </a:r>
-            <a:r>
-              <a:rPr lang="hu-HU" sz="1800" dirty="0" err="1"/>
-              <a:t>Embedding</a:t>
-            </a:r>
-            <a:r>
-              <a:rPr lang="hu-HU" sz="1800" dirty="0"/>
-              <a:t>: </a:t>
-            </a:r>
-            <a:r>
-              <a:rPr lang="hu-HU" sz="1800" dirty="0" err="1"/>
-              <a:t>Basics</a:t>
-            </a:r>
-            <a:r>
-              <a:rPr lang="hu-HU" sz="1800" dirty="0"/>
-              <a:t>, </a:t>
-            </a:r>
-            <a:r>
-              <a:rPr lang="hu-HU" sz="1800" dirty="0" err="1"/>
-              <a:t>Medium</a:t>
-            </a:r>
-            <a:r>
-              <a:rPr lang="hu-HU" sz="1800" dirty="0"/>
-              <a:t>, </a:t>
-            </a:r>
-            <a:r>
-              <a:rPr lang="hu-HU" sz="1800" dirty="0">
-                <a:hlinkClick r:id="rId3"/>
-              </a:rPr>
-              <a:t>https://medium.com/@hari4om/word-embedding-d816f643140</a:t>
-            </a:r>
-            <a:endParaRPr lang="hu-HU" sz="1800" dirty="0"/>
-          </a:p>
-          <a:p>
-            <a:r>
-              <a:rPr lang="hu-HU" sz="1800" dirty="0"/>
-              <a:t>[2] </a:t>
-            </a:r>
-            <a:r>
-              <a:rPr lang="hu-HU" sz="1800" dirty="0" err="1"/>
-              <a:t>Varun</a:t>
-            </a:r>
-            <a:r>
-              <a:rPr lang="hu-HU" sz="1800" dirty="0"/>
-              <a:t>, (2020.09.27.), </a:t>
-            </a:r>
-            <a:r>
-              <a:rPr lang="hu-HU" sz="1800" dirty="0" err="1"/>
-              <a:t>Cosine</a:t>
-            </a:r>
-            <a:r>
-              <a:rPr lang="hu-HU" sz="1800" dirty="0"/>
-              <a:t> </a:t>
-            </a:r>
-            <a:r>
-              <a:rPr lang="hu-HU" sz="1800" dirty="0" err="1"/>
-              <a:t>similarity</a:t>
-            </a:r>
-            <a:r>
-              <a:rPr lang="hu-HU" sz="1800" dirty="0"/>
-              <a:t>: </a:t>
-            </a:r>
-            <a:r>
-              <a:rPr lang="hu-HU" sz="1800" dirty="0" err="1"/>
-              <a:t>How</a:t>
-            </a:r>
-            <a:r>
-              <a:rPr lang="hu-HU" sz="1800" dirty="0"/>
-              <a:t> </a:t>
-            </a:r>
-            <a:r>
-              <a:rPr lang="hu-HU" sz="1800" dirty="0" err="1"/>
-              <a:t>does</a:t>
-            </a:r>
-            <a:r>
-              <a:rPr lang="hu-HU" sz="1800" dirty="0"/>
-              <a:t> </a:t>
-            </a:r>
-            <a:r>
-              <a:rPr lang="hu-HU" sz="1800" dirty="0" err="1"/>
-              <a:t>it</a:t>
-            </a:r>
-            <a:r>
-              <a:rPr lang="hu-HU" sz="1800" dirty="0"/>
-              <a:t> </a:t>
-            </a:r>
-            <a:r>
-              <a:rPr lang="hu-HU" sz="1800" dirty="0" err="1"/>
-              <a:t>measure</a:t>
-            </a:r>
-            <a:r>
-              <a:rPr lang="hu-HU" sz="1800" dirty="0"/>
-              <a:t> </a:t>
-            </a:r>
-            <a:r>
-              <a:rPr lang="hu-HU" sz="1800" dirty="0" err="1"/>
-              <a:t>the</a:t>
-            </a:r>
-            <a:r>
-              <a:rPr lang="hu-HU" sz="1800" dirty="0"/>
-              <a:t> </a:t>
-            </a:r>
-            <a:r>
-              <a:rPr lang="hu-HU" sz="1800" dirty="0" err="1"/>
-              <a:t>similarity</a:t>
-            </a:r>
-            <a:r>
-              <a:rPr lang="hu-HU" sz="1800" dirty="0"/>
-              <a:t>, </a:t>
-            </a:r>
-            <a:r>
-              <a:rPr lang="hu-HU" sz="1800" dirty="0" err="1"/>
-              <a:t>Maths</a:t>
-            </a:r>
-            <a:r>
-              <a:rPr lang="hu-HU" sz="1800" dirty="0"/>
-              <a:t> </a:t>
-            </a:r>
-            <a:r>
-              <a:rPr lang="hu-HU" sz="1800" dirty="0" err="1"/>
-              <a:t>behind</a:t>
-            </a:r>
-            <a:r>
-              <a:rPr lang="hu-HU" sz="1800" dirty="0"/>
-              <a:t> and </a:t>
-            </a:r>
-            <a:r>
-              <a:rPr lang="hu-HU" sz="1800" dirty="0" err="1"/>
-              <a:t>usage</a:t>
-            </a:r>
-            <a:r>
-              <a:rPr lang="hu-HU" sz="1800" dirty="0"/>
-              <a:t> in Python, towardsdatascience.com ,</a:t>
-            </a:r>
-            <a:r>
-              <a:rPr lang="hu-HU" sz="1800" dirty="0">
-                <a:hlinkClick r:id="rId4"/>
-              </a:rPr>
-              <a:t>https://towardsdatascience.com/cosine-similarity-how-does-it-measure-the-similarity-maths-behind-and-usage-in-python-50ad30aad7db/</a:t>
-            </a:r>
-            <a:endParaRPr lang="hu-HU" sz="1800" dirty="0"/>
-          </a:p>
-          <a:p>
-            <a:r>
-              <a:rPr lang="hu-HU" sz="1800" dirty="0"/>
-              <a:t>[3] </a:t>
-            </a:r>
-            <a:r>
-              <a:rPr lang="hu-HU" sz="1800" dirty="0" err="1">
-                <a:solidFill>
-                  <a:srgbClr val="000000"/>
-                </a:solidFill>
-                <a:effectLst/>
-              </a:rPr>
-              <a:t>Pranav</a:t>
-            </a:r>
-            <a:r>
-              <a:rPr lang="hu-HU" sz="1800" dirty="0">
-                <a:solidFill>
-                  <a:srgbClr val="000000"/>
-                </a:solidFill>
-                <a:effectLst/>
-              </a:rPr>
-              <a:t> </a:t>
-            </a:r>
-            <a:r>
-              <a:rPr lang="hu-HU" sz="1800" dirty="0" err="1">
-                <a:solidFill>
-                  <a:srgbClr val="000000"/>
-                </a:solidFill>
-                <a:effectLst/>
-              </a:rPr>
-              <a:t>Rajpurkar</a:t>
-            </a:r>
-            <a:r>
-              <a:rPr lang="hu-HU" sz="1800" dirty="0">
-                <a:solidFill>
-                  <a:srgbClr val="000000"/>
-                </a:solidFill>
-                <a:effectLst/>
-              </a:rPr>
-              <a:t>, </a:t>
-            </a:r>
-            <a:r>
-              <a:rPr lang="hu-HU" sz="1800" dirty="0" err="1">
-                <a:solidFill>
-                  <a:srgbClr val="000000"/>
-                </a:solidFill>
-                <a:effectLst/>
-              </a:rPr>
-              <a:t>Jian</a:t>
-            </a:r>
-            <a:r>
-              <a:rPr lang="hu-HU" sz="1800" dirty="0">
-                <a:solidFill>
-                  <a:srgbClr val="000000"/>
-                </a:solidFill>
-                <a:effectLst/>
-              </a:rPr>
-              <a:t> </a:t>
-            </a:r>
-            <a:r>
-              <a:rPr lang="hu-HU" sz="1800" dirty="0" err="1">
-                <a:solidFill>
-                  <a:srgbClr val="000000"/>
-                </a:solidFill>
-                <a:effectLst/>
-              </a:rPr>
-              <a:t>Zhang</a:t>
-            </a:r>
-            <a:r>
-              <a:rPr lang="hu-HU" sz="1800" dirty="0">
-                <a:solidFill>
-                  <a:srgbClr val="000000"/>
-                </a:solidFill>
-                <a:effectLst/>
-              </a:rPr>
-              <a:t>, </a:t>
-            </a:r>
-            <a:r>
-              <a:rPr lang="hu-HU" sz="1800" dirty="0">
-                <a:effectLst/>
-              </a:rPr>
-              <a:t>Konstantin</a:t>
-            </a:r>
-            <a:r>
-              <a:rPr lang="hu-HU" sz="1800" dirty="0">
-                <a:solidFill>
-                  <a:srgbClr val="000000"/>
-                </a:solidFill>
-                <a:effectLst/>
-              </a:rPr>
-              <a:t> </a:t>
-            </a:r>
-            <a:r>
-              <a:rPr lang="hu-HU" sz="1800" dirty="0" err="1">
-                <a:solidFill>
-                  <a:srgbClr val="000000"/>
-                </a:solidFill>
-                <a:effectLst/>
-              </a:rPr>
-              <a:t>Lopyrev</a:t>
-            </a:r>
-            <a:r>
-              <a:rPr lang="hu-HU" sz="1800" dirty="0">
-                <a:solidFill>
-                  <a:srgbClr val="000000"/>
-                </a:solidFill>
-                <a:effectLst/>
-              </a:rPr>
-              <a:t>, Percy </a:t>
-            </a:r>
-            <a:r>
-              <a:rPr lang="hu-HU" sz="1800" dirty="0" err="1">
-                <a:solidFill>
-                  <a:srgbClr val="000000"/>
-                </a:solidFill>
-                <a:effectLst/>
-              </a:rPr>
-              <a:t>Liang</a:t>
-            </a:r>
-            <a:r>
-              <a:rPr lang="hu-HU" sz="1800" dirty="0">
-                <a:solidFill>
-                  <a:srgbClr val="000000"/>
-                </a:solidFill>
-                <a:effectLst/>
-              </a:rPr>
-              <a:t>, (2016.06.16.),</a:t>
-            </a:r>
-            <a:r>
-              <a:rPr lang="hu-HU" sz="1800" dirty="0" err="1">
-                <a:solidFill>
-                  <a:srgbClr val="000000"/>
-                </a:solidFill>
-                <a:effectLst/>
-              </a:rPr>
-              <a:t>SQuAD</a:t>
-            </a:r>
-            <a:r>
-              <a:rPr lang="hu-HU" sz="1800" dirty="0">
-                <a:solidFill>
-                  <a:srgbClr val="000000"/>
-                </a:solidFill>
-                <a:effectLst/>
-              </a:rPr>
-              <a:t>:</a:t>
-            </a:r>
-          </a:p>
-          <a:p>
-            <a:r>
-              <a:rPr lang="hu-HU" sz="1800" dirty="0">
-                <a:solidFill>
-                  <a:srgbClr val="000000"/>
-                </a:solidFill>
-                <a:effectLst/>
-              </a:rPr>
-              <a:t>100,000+ </a:t>
-            </a:r>
-            <a:r>
-              <a:rPr lang="hu-HU" sz="1800" dirty="0" err="1">
-                <a:solidFill>
-                  <a:srgbClr val="000000"/>
-                </a:solidFill>
-                <a:effectLst/>
-              </a:rPr>
-              <a:t>Questions</a:t>
-            </a:r>
-            <a:r>
-              <a:rPr lang="hu-HU" sz="1800" dirty="0">
-                <a:solidFill>
-                  <a:srgbClr val="000000"/>
-                </a:solidFill>
-                <a:effectLst/>
-              </a:rPr>
-              <a:t> </a:t>
-            </a:r>
-            <a:r>
-              <a:rPr lang="hu-HU" sz="1800" dirty="0" err="1">
-                <a:solidFill>
-                  <a:srgbClr val="000000"/>
-                </a:solidFill>
-                <a:effectLst/>
-              </a:rPr>
-              <a:t>for</a:t>
-            </a:r>
-            <a:r>
-              <a:rPr lang="hu-HU" sz="1800" dirty="0">
-                <a:solidFill>
-                  <a:srgbClr val="000000"/>
-                </a:solidFill>
-                <a:effectLst/>
-              </a:rPr>
-              <a:t> </a:t>
-            </a:r>
-            <a:r>
-              <a:rPr lang="hu-HU" sz="1800" dirty="0" err="1">
-                <a:solidFill>
-                  <a:srgbClr val="000000"/>
-                </a:solidFill>
-                <a:effectLst/>
-              </a:rPr>
-              <a:t>Machine</a:t>
-            </a:r>
-            <a:r>
-              <a:rPr lang="hu-HU" sz="1800" dirty="0">
-                <a:solidFill>
-                  <a:srgbClr val="000000"/>
-                </a:solidFill>
-                <a:effectLst/>
-              </a:rPr>
-              <a:t> </a:t>
-            </a:r>
-            <a:r>
-              <a:rPr lang="hu-HU" sz="1800" dirty="0" err="1">
-                <a:solidFill>
-                  <a:srgbClr val="000000"/>
-                </a:solidFill>
-                <a:effectLst/>
-              </a:rPr>
-              <a:t>Comprehension</a:t>
-            </a:r>
-            <a:r>
-              <a:rPr lang="hu-HU" sz="1800" dirty="0">
-                <a:solidFill>
-                  <a:srgbClr val="000000"/>
-                </a:solidFill>
-                <a:effectLst/>
-              </a:rPr>
-              <a:t> of Text, </a:t>
-            </a:r>
-            <a:r>
-              <a:rPr lang="hu-HU" sz="1800" dirty="0" err="1">
-                <a:solidFill>
-                  <a:srgbClr val="000000"/>
-                </a:solidFill>
-                <a:effectLst/>
-              </a:rPr>
-              <a:t>ArXiv</a:t>
-            </a:r>
-            <a:r>
-              <a:rPr lang="hu-HU" sz="1800" dirty="0">
-                <a:solidFill>
-                  <a:srgbClr val="000000"/>
-                </a:solidFill>
-                <a:effectLst/>
-              </a:rPr>
-              <a:t>, </a:t>
-            </a:r>
-            <a:r>
-              <a:rPr lang="hu-HU" sz="1800" b="0" i="0" u="sng" dirty="0">
-                <a:effectLst/>
-                <a:hlinkClick r:id="rId5"/>
-              </a:rPr>
-              <a:t>https://doi.org/10.48550/arXiv.1606.05250</a:t>
-            </a:r>
-            <a:endParaRPr lang="hu-HU" sz="1800" dirty="0"/>
-          </a:p>
-          <a:p>
-            <a:endParaRPr lang="hu-HU" sz="2000" dirty="0"/>
-          </a:p>
-        </p:txBody>
-      </p:sp>
-      <p:sp>
-        <p:nvSpPr>
-          <p:cNvPr id="4" name="Dátum helye 3">
-            <a:extLst>
-              <a:ext uri="{FF2B5EF4-FFF2-40B4-BE49-F238E27FC236}">
-                <a16:creationId xmlns:a16="http://schemas.microsoft.com/office/drawing/2014/main" id="{E3AFDC56-C173-DBE4-4AB5-B1829C2CB1E8}"/>
-              </a:ext>
-            </a:extLst>
-          </p:cNvPr>
-          <p:cNvSpPr>
-            <a:spLocks noGrp="1"/>
-          </p:cNvSpPr>
-          <p:nvPr>
-            <p:ph type="dt" sz="half" idx="10"/>
-          </p:nvPr>
-        </p:nvSpPr>
-        <p:spPr/>
-        <p:txBody>
-          <a:bodyPr/>
-          <a:lstStyle/>
-          <a:p>
-            <a:endParaRPr lang="hu-HU" dirty="0"/>
-          </a:p>
-        </p:txBody>
-      </p:sp>
-      <p:sp>
-        <p:nvSpPr>
-          <p:cNvPr id="5" name="Dia számának helye 4">
-            <a:extLst>
-              <a:ext uri="{FF2B5EF4-FFF2-40B4-BE49-F238E27FC236}">
-                <a16:creationId xmlns:a16="http://schemas.microsoft.com/office/drawing/2014/main" id="{68737DFA-5AEE-8E85-0BBC-53632C2E9510}"/>
-              </a:ext>
-            </a:extLst>
-          </p:cNvPr>
-          <p:cNvSpPr>
-            <a:spLocks noGrp="1"/>
-          </p:cNvSpPr>
-          <p:nvPr>
-            <p:ph type="sldNum" sz="quarter" idx="12"/>
-          </p:nvPr>
-        </p:nvSpPr>
-        <p:spPr/>
-        <p:txBody>
-          <a:bodyPr/>
-          <a:lstStyle/>
-          <a:p>
-            <a:pPr marL="0" algn="l" defTabSz="914400" rtl="0" eaLnBrk="1" latinLnBrk="0" hangingPunct="1"/>
-            <a:endParaRPr lang="hu-HU" dirty="0"/>
-          </a:p>
-        </p:txBody>
-      </p:sp>
-    </p:spTree>
-    <p:extLst>
-      <p:ext uri="{BB962C8B-B14F-4D97-AF65-F5344CB8AC3E}">
-        <p14:creationId xmlns:p14="http://schemas.microsoft.com/office/powerpoint/2010/main" val="2015096485"/>
       </p:ext>
     </p:extLst>
   </p:cSld>
@@ -17691,7 +18028,7 @@
           <a:p>
             <a:fld id="{9A3D4093-34E7-DB4F-8E21-29319E040103}" type="datetime1">
               <a:rPr lang="hu-HU" smtClean="0"/>
-              <a:t>2025. 12. 28.</a:t>
+              <a:t>2026. 01. 05.</a:t>
             </a:fld>
             <a:endParaRPr lang="hu-HU"/>
           </a:p>
@@ -18306,7 +18643,7 @@
           <a:p>
             <a:fld id="{EDCD7766-E8FF-F045-B46B-9108152DAA94}" type="datetime1">
               <a:rPr lang="hu-HU" smtClean="0"/>
-              <a:t>2025. 12. 28.</a:t>
+              <a:t>2026. 01. 05.</a:t>
             </a:fld>
             <a:endParaRPr lang="hu-HU"/>
           </a:p>
@@ -18526,7 +18863,7 @@
           <a:p>
             <a:fld id="{77E87468-36DB-7F46-920C-0F19CC9A9134}" type="datetime1">
               <a:rPr lang="hu-HU" smtClean="0"/>
-              <a:t>2025. 12. 28.</a:t>
+              <a:t>2026. 01. 05.</a:t>
             </a:fld>
             <a:endParaRPr lang="hu-HU"/>
           </a:p>
@@ -19578,7 +19915,7 @@
             </a:pPr>
             <a:fld id="{D24C2032-E76D-2848-BAF7-0E597B598D68}" type="datetime1">
               <a:rPr lang="hu-HU" smtClean="0"/>
-              <a:t>2025. 12. 28.</a:t>
+              <a:t>2026. 01. 05.</a:t>
             </a:fld>
             <a:endParaRPr lang="hu-HU"/>
           </a:p>
@@ -20188,7 +20525,7 @@
                   </a:schemeClr>
                 </a:solidFill>
               </a:rPr>
-              <a:t>2025. 12. 28.</a:t>
+              <a:t>2026. 01. 05.</a:t>
             </a:fld>
             <a:endParaRPr lang="en-US" dirty="0">
               <a:solidFill>
@@ -20922,7 +21259,7 @@
             </a:pPr>
             <a:fld id="{05B90B19-A1FC-5745-9E3E-9A58B2658B29}" type="datetime1">
               <a:rPr lang="hu-HU" smtClean="0"/>
-              <a:t>2025. 12. 28.</a:t>
+              <a:t>2026. 01. 05.</a:t>
             </a:fld>
             <a:endParaRPr lang="hu-HU"/>
           </a:p>

</xml_diff>